<commit_message>
YYT: update autograder and bonus
</commit_message>
<xml_diff>
--- a/tutorial/T05/tut05.pptx
+++ b/tutorial/T05/tut05.pptx
@@ -24,17 +24,17 @@
     <p:sldId id="295" r:id="rId15"/>
     <p:sldId id="296" r:id="rId16"/>
     <p:sldId id="281" r:id="rId17"/>
-    <p:sldId id="297" r:id="rId18"/>
+    <p:sldId id="301" r:id="rId18"/>
     <p:sldId id="298" r:id="rId19"/>
     <p:sldId id="275" r:id="rId20"/>
     <p:sldId id="279" r:id="rId21"/>
     <p:sldId id="299" r:id="rId22"/>
     <p:sldId id="280" r:id="rId23"/>
     <p:sldId id="300" r:id="rId24"/>
-    <p:sldId id="272" r:id="rId25"/>
-    <p:sldId id="277" r:id="rId26"/>
-    <p:sldId id="278" r:id="rId27"/>
-    <p:sldId id="282" r:id="rId28"/>
+    <p:sldId id="282" r:id="rId25"/>
+    <p:sldId id="272" r:id="rId26"/>
+    <p:sldId id="277" r:id="rId27"/>
+    <p:sldId id="278" r:id="rId28"/>
   </p:sldIdLst>
   <p:sldSz cx="12192000" cy="6858000"/>
   <p:notesSz cx="6858000" cy="9144000"/>
@@ -1110,7 +1110,7 @@
           <a:p>
             <a:fld id="{3D57E1DE-EE62-4F4F-8498-944AA5CE2831}" type="datetimeFigureOut">
               <a:rPr lang="zh-CN" altLang="en-US" smtClean="0"/>
-              <a:t>2025/2/11</a:t>
+              <a:t>2025/2/12</a:t>
             </a:fld>
             <a:endParaRPr lang="zh-CN" altLang="en-US"/>
           </a:p>
@@ -1543,7 +1543,7 @@
     </p:spTree>
     <p:extLst>
       <p:ext uri="{BB962C8B-B14F-4D97-AF65-F5344CB8AC3E}">
-        <p14:creationId xmlns:p14="http://schemas.microsoft.com/office/powerpoint/2010/main" val="2187190685"/>
+        <p14:creationId xmlns:p14="http://schemas.microsoft.com/office/powerpoint/2010/main" val="2701342721"/>
       </p:ext>
     </p:extLst>
   </p:cSld>
@@ -1786,7 +1786,7 @@
           <a:p>
             <a:fld id="{34BC58A6-A143-45AB-9298-8A14980D6F04}" type="slidenum">
               <a:rPr lang="zh-CN" altLang="en-US" smtClean="0"/>
-              <a:t>25</a:t>
+              <a:t>26</a:t>
             </a:fld>
             <a:endParaRPr lang="zh-CN" altLang="en-US"/>
           </a:p>
@@ -1954,7 +1954,7 @@
           <a:p>
             <a:fld id="{2425905D-C0C4-D040-B3F5-79CCA23FA4EB}" type="datetimeFigureOut">
               <a:rPr lang="en-US" smtClean="0"/>
-              <a:t>2/11/25</a:t>
+              <a:t>2/12/25</a:t>
             </a:fld>
             <a:endParaRPr lang="en-US"/>
           </a:p>
@@ -2154,7 +2154,7 @@
           <a:p>
             <a:fld id="{2425905D-C0C4-D040-B3F5-79CCA23FA4EB}" type="datetimeFigureOut">
               <a:rPr lang="en-US" smtClean="0"/>
-              <a:t>2/11/25</a:t>
+              <a:t>2/12/25</a:t>
             </a:fld>
             <a:endParaRPr lang="en-US"/>
           </a:p>
@@ -2364,7 +2364,7 @@
           <a:p>
             <a:fld id="{2425905D-C0C4-D040-B3F5-79CCA23FA4EB}" type="datetimeFigureOut">
               <a:rPr lang="en-US" smtClean="0"/>
-              <a:t>2/11/25</a:t>
+              <a:t>2/12/25</a:t>
             </a:fld>
             <a:endParaRPr lang="en-US"/>
           </a:p>
@@ -2564,7 +2564,7 @@
           <a:p>
             <a:fld id="{2425905D-C0C4-D040-B3F5-79CCA23FA4EB}" type="datetimeFigureOut">
               <a:rPr lang="en-US" smtClean="0"/>
-              <a:t>2/11/25</a:t>
+              <a:t>2/12/25</a:t>
             </a:fld>
             <a:endParaRPr lang="en-US"/>
           </a:p>
@@ -2840,7 +2840,7 @@
           <a:p>
             <a:fld id="{2425905D-C0C4-D040-B3F5-79CCA23FA4EB}" type="datetimeFigureOut">
               <a:rPr lang="en-US" smtClean="0"/>
-              <a:t>2/11/25</a:t>
+              <a:t>2/12/25</a:t>
             </a:fld>
             <a:endParaRPr lang="en-US"/>
           </a:p>
@@ -3108,7 +3108,7 @@
           <a:p>
             <a:fld id="{2425905D-C0C4-D040-B3F5-79CCA23FA4EB}" type="datetimeFigureOut">
               <a:rPr lang="en-US" smtClean="0"/>
-              <a:t>2/11/25</a:t>
+              <a:t>2/12/25</a:t>
             </a:fld>
             <a:endParaRPr lang="en-US"/>
           </a:p>
@@ -3523,7 +3523,7 @@
           <a:p>
             <a:fld id="{2425905D-C0C4-D040-B3F5-79CCA23FA4EB}" type="datetimeFigureOut">
               <a:rPr lang="en-US" smtClean="0"/>
-              <a:t>2/11/25</a:t>
+              <a:t>2/12/25</a:t>
             </a:fld>
             <a:endParaRPr lang="en-US"/>
           </a:p>
@@ -3665,7 +3665,7 @@
           <a:p>
             <a:fld id="{2425905D-C0C4-D040-B3F5-79CCA23FA4EB}" type="datetimeFigureOut">
               <a:rPr lang="en-US" smtClean="0"/>
-              <a:t>2/11/25</a:t>
+              <a:t>2/12/25</a:t>
             </a:fld>
             <a:endParaRPr lang="en-US"/>
           </a:p>
@@ -3778,7 +3778,7 @@
           <a:p>
             <a:fld id="{2425905D-C0C4-D040-B3F5-79CCA23FA4EB}" type="datetimeFigureOut">
               <a:rPr lang="en-US" smtClean="0"/>
-              <a:t>2/11/25</a:t>
+              <a:t>2/12/25</a:t>
             </a:fld>
             <a:endParaRPr lang="en-US"/>
           </a:p>
@@ -4091,7 +4091,7 @@
           <a:p>
             <a:fld id="{2425905D-C0C4-D040-B3F5-79CCA23FA4EB}" type="datetimeFigureOut">
               <a:rPr lang="en-US" smtClean="0"/>
-              <a:t>2/11/25</a:t>
+              <a:t>2/12/25</a:t>
             </a:fld>
             <a:endParaRPr lang="en-US"/>
           </a:p>
@@ -4380,7 +4380,7 @@
           <a:p>
             <a:fld id="{2425905D-C0C4-D040-B3F5-79CCA23FA4EB}" type="datetimeFigureOut">
               <a:rPr lang="en-US" smtClean="0"/>
-              <a:t>2/11/25</a:t>
+              <a:t>2/12/25</a:t>
             </a:fld>
             <a:endParaRPr lang="en-US"/>
           </a:p>
@@ -4623,7 +4623,7 @@
           <a:p>
             <a:fld id="{2425905D-C0C4-D040-B3F5-79CCA23FA4EB}" type="datetimeFigureOut">
               <a:rPr lang="en-US" smtClean="0"/>
-              <a:t>2/11/25</a:t>
+              <a:t>2/12/25</a:t>
             </a:fld>
             <a:endParaRPr lang="en-US"/>
           </a:p>
@@ -5510,7 +5510,7 @@
           <a:lstStyle/>
           <a:p>
             <a:r>
-              <a:rPr lang="en-GB" altLang="zh-CN" dirty="0"/>
+              <a:rPr lang="en-GB" altLang="zh-CN" b="1" dirty="0"/>
               <a:t>Common Techniques: </a:t>
             </a:r>
           </a:p>
@@ -5884,14 +5884,14 @@
             <p:ph idx="1"/>
             <p:extLst>
               <p:ext uri="{D42A27DB-BD31-4B8C-83A1-F6EECF244321}">
-                <p14:modId xmlns:p14="http://schemas.microsoft.com/office/powerpoint/2010/main" val="2532570394"/>
+                <p14:modId xmlns:p14="http://schemas.microsoft.com/office/powerpoint/2010/main" val="648416321"/>
               </p:ext>
             </p:extLst>
           </p:nvPr>
         </p:nvGraphicFramePr>
         <p:xfrm>
-          <a:off x="838200" y="1825625"/>
-          <a:ext cx="10515600" cy="3255256"/>
+          <a:off x="838200" y="1825624"/>
+          <a:ext cx="10515600" cy="4062084"/>
         </p:xfrm>
         <a:graphic>
           <a:graphicData uri="http://schemas.openxmlformats.org/drawingml/2006/table">
@@ -5915,7 +5915,7 @@
                   </a:extLst>
                 </a:gridCol>
               </a:tblGrid>
-              <a:tr h="504530">
+              <a:tr h="561548">
                 <a:tc>
                   <a:txBody>
                     <a:bodyPr/>
@@ -5923,10 +5923,10 @@
                     <a:p>
                       <a:pPr algn="ctr"/>
                       <a:r>
-                        <a:rPr lang="en-US" altLang="zh-CN" dirty="0"/>
+                        <a:rPr lang="en-US" altLang="zh-CN" sz="2400" dirty="0"/>
                         <a:t>Go-Back-N</a:t>
                       </a:r>
-                      <a:endParaRPr lang="zh-CN" altLang="en-US" dirty="0"/>
+                      <a:endParaRPr lang="zh-CN" altLang="en-US" sz="2400" dirty="0"/>
                     </a:p>
                   </a:txBody>
                   <a:tcPr/>
@@ -5938,10 +5938,10 @@
                     <a:p>
                       <a:pPr algn="ctr"/>
                       <a:r>
-                        <a:rPr lang="en-GB" altLang="zh-CN" dirty="0"/>
+                        <a:rPr lang="en-GB" altLang="zh-CN" sz="2400" dirty="0"/>
                         <a:t>Selective Repeat</a:t>
                       </a:r>
-                      <a:endParaRPr lang="zh-CN" altLang="en-US" dirty="0"/>
+                      <a:endParaRPr lang="zh-CN" altLang="en-US" sz="2400" dirty="0"/>
                     </a:p>
                   </a:txBody>
                   <a:tcPr/>
@@ -5952,7 +5952,7 @@
                   </a:ext>
                 </a:extLst>
               </a:tr>
-              <a:tr h="504530">
+              <a:tr h="561548">
                 <a:tc>
                   <a:txBody>
                     <a:bodyPr/>
@@ -5960,10 +5960,10 @@
                     <a:p>
                       <a:pPr algn="ctr"/>
                       <a:r>
-                        <a:rPr lang="en-GB" altLang="zh-CN" dirty="0"/>
+                        <a:rPr lang="en-GB" altLang="zh-CN" sz="2400" dirty="0"/>
                         <a:t>Used with sliding window</a:t>
                       </a:r>
-                      <a:endParaRPr lang="zh-CN" altLang="en-US" dirty="0"/>
+                      <a:endParaRPr lang="zh-CN" altLang="en-US" sz="2400" dirty="0"/>
                     </a:p>
                   </a:txBody>
                   <a:tcPr/>
@@ -5975,10 +5975,10 @@
                     <a:p>
                       <a:pPr algn="ctr"/>
                       <a:r>
-                        <a:rPr lang="en-GB" altLang="zh-CN" dirty="0"/>
+                        <a:rPr lang="en-GB" altLang="zh-CN" sz="2400" dirty="0"/>
                         <a:t>Used with sliding window</a:t>
                       </a:r>
-                      <a:endParaRPr lang="zh-CN" altLang="en-US" dirty="0"/>
+                      <a:endParaRPr lang="zh-CN" altLang="en-US" sz="2400" dirty="0"/>
                     </a:p>
                   </a:txBody>
                   <a:tcPr/>
@@ -5989,7 +5989,7 @@
                   </a:ext>
                 </a:extLst>
               </a:tr>
-              <a:tr h="870833">
+              <a:tr h="1119511">
                 <a:tc>
                   <a:txBody>
                     <a:bodyPr/>
@@ -5997,10 +5997,10 @@
                     <a:p>
                       <a:pPr algn="ctr"/>
                       <a:r>
-                        <a:rPr lang="en-GB" altLang="zh-CN" dirty="0"/>
+                        <a:rPr lang="en-GB" altLang="zh-CN" sz="2400" dirty="0"/>
                         <a:t>Receiver only accepts packets in-order, and discards out-of-order packets (i.e. does not ACK nor buffer). </a:t>
                       </a:r>
-                      <a:endParaRPr lang="zh-CN" altLang="en-US" dirty="0"/>
+                      <a:endParaRPr lang="zh-CN" altLang="en-US" sz="2400" dirty="0"/>
                     </a:p>
                   </a:txBody>
                   <a:tcPr/>
@@ -6012,10 +6012,10 @@
                     <a:p>
                       <a:pPr algn="ctr"/>
                       <a:r>
-                        <a:rPr lang="en-GB" altLang="zh-CN" dirty="0"/>
+                        <a:rPr lang="en-GB" altLang="zh-CN" sz="2400" dirty="0"/>
                         <a:t>Receiver accepts any packet that is in its window, possibly buffering until it can recreate them in-order</a:t>
                       </a:r>
-                      <a:endParaRPr lang="zh-CN" altLang="en-US" dirty="0"/>
+                      <a:endParaRPr lang="zh-CN" altLang="en-US" sz="2400" dirty="0"/>
                     </a:p>
                   </a:txBody>
                   <a:tcPr/>
@@ -6026,7 +6026,7 @@
                   </a:ext>
                 </a:extLst>
               </a:tr>
-              <a:tr h="504530">
+              <a:tr h="561548">
                 <a:tc>
                   <a:txBody>
                     <a:bodyPr/>
@@ -6034,10 +6034,10 @@
                     <a:p>
                       <a:pPr algn="ctr"/>
                       <a:r>
-                        <a:rPr lang="en-GB" altLang="zh-CN" dirty="0"/>
+                        <a:rPr lang="en-GB" altLang="zh-CN" sz="2400" dirty="0"/>
                         <a:t>Cumulative ACKs</a:t>
                       </a:r>
-                      <a:endParaRPr lang="zh-CN" altLang="en-US" dirty="0"/>
+                      <a:endParaRPr lang="zh-CN" altLang="en-US" sz="2400" dirty="0"/>
                     </a:p>
                   </a:txBody>
                   <a:tcPr/>
@@ -6049,10 +6049,10 @@
                     <a:p>
                       <a:pPr algn="ctr"/>
                       <a:r>
-                        <a:rPr lang="en-GB" altLang="zh-CN" dirty="0"/>
+                        <a:rPr lang="en-GB" altLang="zh-CN" sz="2400" dirty="0"/>
                         <a:t>Selective ACKs. </a:t>
                       </a:r>
-                      <a:endParaRPr lang="zh-CN" altLang="en-US" dirty="0"/>
+                      <a:endParaRPr lang="zh-CN" altLang="en-US" sz="2400" dirty="0"/>
                     </a:p>
                   </a:txBody>
                   <a:tcPr/>
@@ -6063,7 +6063,7 @@
                   </a:ext>
                 </a:extLst>
               </a:tr>
-              <a:tr h="870833">
+              <a:tr h="1119511">
                 <a:tc>
                   <a:txBody>
                     <a:bodyPr/>
@@ -6071,18 +6071,18 @@
                     <a:p>
                       <a:pPr algn="ctr"/>
                       <a:r>
-                        <a:rPr lang="en-GB" altLang="zh-CN" dirty="0"/>
+                        <a:rPr lang="en-GB" altLang="zh-CN" sz="2400" dirty="0"/>
                         <a:t>Sender maintains one timer (for first outstanding ACK) and resends </a:t>
                       </a:r>
                       <a:r>
-                        <a:rPr lang="en-GB" altLang="zh-CN" b="1" dirty="0"/>
+                        <a:rPr lang="en-GB" altLang="zh-CN" sz="2400" b="1" dirty="0"/>
                         <a:t>n</a:t>
                       </a:r>
                       <a:r>
-                        <a:rPr lang="en-GB" altLang="zh-CN" dirty="0"/>
+                        <a:rPr lang="en-GB" altLang="zh-CN" sz="2400" dirty="0"/>
                         <a:t> packets if the timer expires. </a:t>
                       </a:r>
-                      <a:endParaRPr lang="zh-CN" altLang="en-US" dirty="0"/>
+                      <a:endParaRPr lang="zh-CN" altLang="en-US" sz="2400" dirty="0"/>
                     </a:p>
                   </a:txBody>
                   <a:tcPr/>
@@ -6094,10 +6094,10 @@
                     <a:p>
                       <a:pPr algn="ctr"/>
                       <a:r>
-                        <a:rPr lang="en-GB" altLang="zh-CN" dirty="0"/>
+                        <a:rPr lang="en-GB" altLang="zh-CN" sz="2400" dirty="0"/>
                         <a:t>Sender maintains one timer per packet, resending just that packet if ACK is not received in time.</a:t>
                       </a:r>
-                      <a:endParaRPr lang="zh-CN" altLang="en-US" dirty="0"/>
+                      <a:endParaRPr lang="zh-CN" altLang="en-US" sz="2400" dirty="0"/>
                     </a:p>
                   </a:txBody>
                   <a:tcPr/>
@@ -6360,8 +6360,8 @@
         </p:blipFill>
         <p:spPr>
           <a:xfrm>
-            <a:off x="3525148" y="2540508"/>
-            <a:ext cx="4725586" cy="3212748"/>
+            <a:off x="3422011" y="2470389"/>
+            <a:ext cx="4931860" cy="3352986"/>
           </a:xfrm>
           <a:prstGeom prst="rect">
             <a:avLst/>
@@ -6420,7 +6420,7 @@
         </p:nvSpPr>
         <p:spPr>
           <a:xfrm>
-            <a:off x="3729162" y="5708828"/>
+            <a:off x="3729162" y="5893494"/>
             <a:ext cx="4317558" cy="369332"/>
           </a:xfrm>
           <a:prstGeom prst="rect">
@@ -6792,7 +6792,7 @@
     </p:spTree>
     <p:extLst>
       <p:ext uri="{BB962C8B-B14F-4D97-AF65-F5344CB8AC3E}">
-        <p14:creationId xmlns:p14="http://schemas.microsoft.com/office/powerpoint/2010/main" val="840224855"/>
+        <p14:creationId xmlns:p14="http://schemas.microsoft.com/office/powerpoint/2010/main" val="1252659738"/>
       </p:ext>
     </p:extLst>
   </p:cSld>
@@ -8733,866 +8733,6 @@
       </p:grpSpPr>
       <p:sp>
         <p:nvSpPr>
-          <p:cNvPr id="4" name="Rectangle 3">
-            <a:extLst>
-              <a:ext uri="{FF2B5EF4-FFF2-40B4-BE49-F238E27FC236}">
-                <a16:creationId xmlns:a16="http://schemas.microsoft.com/office/drawing/2014/main" id="{A8D2CAE8-E323-A14E-A62F-188A25405FEA}"/>
-              </a:ext>
-            </a:extLst>
-          </p:cNvPr>
-          <p:cNvSpPr/>
-          <p:nvPr/>
-        </p:nvSpPr>
-        <p:spPr>
-          <a:xfrm>
-            <a:off x="5432260" y="3167390"/>
-            <a:ext cx="1651927" cy="646331"/>
-          </a:xfrm>
-          <a:prstGeom prst="rect">
-            <a:avLst/>
-          </a:prstGeom>
-        </p:spPr>
-        <p:txBody>
-          <a:bodyPr wrap="none">
-            <a:spAutoFit/>
-          </a:bodyPr>
-          <a:lstStyle/>
-          <a:p>
-            <a:r>
-              <a:rPr lang="en-US" sz="3600" dirty="0"/>
-              <a:t>Thanks!</a:t>
-            </a:r>
-          </a:p>
-        </p:txBody>
-      </p:sp>
-    </p:spTree>
-    <p:extLst>
-      <p:ext uri="{BB962C8B-B14F-4D97-AF65-F5344CB8AC3E}">
-        <p14:creationId xmlns:p14="http://schemas.microsoft.com/office/powerpoint/2010/main" val="3216618933"/>
-      </p:ext>
-    </p:extLst>
-  </p:cSld>
-  <p:clrMapOvr>
-    <a:masterClrMapping/>
-  </p:clrMapOvr>
-</p:sld>
-</file>
-
-<file path=ppt/slides/slide25.xml><?xml version="1.0" encoding="utf-8"?>
-<p:sld xmlns:a="http://schemas.openxmlformats.org/drawingml/2006/main" xmlns:r="http://schemas.openxmlformats.org/officeDocument/2006/relationships" xmlns:p="http://schemas.openxmlformats.org/presentationml/2006/main">
-  <p:cSld>
-    <p:spTree>
-      <p:nvGrpSpPr>
-        <p:cNvPr id="1" name=""/>
-        <p:cNvGrpSpPr/>
-        <p:nvPr/>
-      </p:nvGrpSpPr>
-      <p:grpSpPr>
-        <a:xfrm>
-          <a:off x="0" y="0"/>
-          <a:ext cx="0" cy="0"/>
-          <a:chOff x="0" y="0"/>
-          <a:chExt cx="0" cy="0"/>
-        </a:xfrm>
-      </p:grpSpPr>
-      <p:sp>
-        <p:nvSpPr>
-          <p:cNvPr id="2" name="Title 1">
-            <a:extLst>
-              <a:ext uri="{FF2B5EF4-FFF2-40B4-BE49-F238E27FC236}">
-                <a16:creationId xmlns:a16="http://schemas.microsoft.com/office/drawing/2014/main" id="{45C79BA1-37A3-5741-B0A1-E64646E4283C}"/>
-              </a:ext>
-            </a:extLst>
-          </p:cNvPr>
-          <p:cNvSpPr>
-            <a:spLocks noGrp="1"/>
-          </p:cNvSpPr>
-          <p:nvPr>
-            <p:ph type="title"/>
-          </p:nvPr>
-        </p:nvSpPr>
-        <p:spPr/>
-        <p:txBody>
-          <a:bodyPr/>
-          <a:lstStyle/>
-          <a:p>
-            <a:r>
-              <a:rPr lang="en-US" altLang="zh-CN" b="1" dirty="0"/>
-              <a:t>Exercise</a:t>
-            </a:r>
-            <a:r>
-              <a:rPr lang="zh-CN" altLang="en-US" b="1" dirty="0"/>
-              <a:t> </a:t>
-            </a:r>
-            <a:r>
-              <a:rPr lang="en-US" b="1" dirty="0"/>
-              <a:t>– Q</a:t>
-            </a:r>
-            <a:r>
-              <a:rPr lang="en-US" altLang="zh-CN" b="1" dirty="0"/>
-              <a:t>4</a:t>
-            </a:r>
-            <a:r>
-              <a:rPr lang="zh-CN" altLang="en-US" b="1" dirty="0"/>
-              <a:t> </a:t>
-            </a:r>
-            <a:r>
-              <a:rPr lang="en-US" altLang="zh-CN" b="1" dirty="0"/>
-              <a:t>(N)ACK</a:t>
-            </a:r>
-            <a:endParaRPr lang="en-US" b="1" dirty="0"/>
-          </a:p>
-        </p:txBody>
-      </p:sp>
-      <p:sp>
-        <p:nvSpPr>
-          <p:cNvPr id="3" name="Content Placeholder 2">
-            <a:extLst>
-              <a:ext uri="{FF2B5EF4-FFF2-40B4-BE49-F238E27FC236}">
-                <a16:creationId xmlns:a16="http://schemas.microsoft.com/office/drawing/2014/main" id="{8F20472D-613F-3748-9CBD-88055CDB4B08}"/>
-              </a:ext>
-            </a:extLst>
-          </p:cNvPr>
-          <p:cNvSpPr>
-            <a:spLocks noGrp="1"/>
-          </p:cNvSpPr>
-          <p:nvPr>
-            <p:ph idx="1"/>
-          </p:nvPr>
-        </p:nvSpPr>
-        <p:spPr>
-          <a:xfrm>
-            <a:off x="838200" y="1571625"/>
-            <a:ext cx="10071100" cy="2705735"/>
-          </a:xfrm>
-        </p:spPr>
-        <p:txBody>
-          <a:bodyPr>
-            <a:normAutofit/>
-          </a:bodyPr>
-          <a:lstStyle/>
-          <a:p>
-            <a:pPr marL="0" indent="0">
-              <a:buNone/>
-            </a:pPr>
-            <a:r>
-              <a:rPr lang="zh-CN" altLang="zh-CN" sz="2400" dirty="0">
-                <a:latin typeface="Arial" panose="020B0604020202020204" pitchFamily="34" charset="0"/>
-                <a:ea typeface="GillSans" panose="020B0502020104020203" pitchFamily="34" charset="-79"/>
-              </a:rPr>
-              <a:t>Consider a reliable data transfer protocol that uses only negative acknowledgments (NACK). Suppose the sender sends data only</a:t>
-            </a:r>
-            <a:r>
-              <a:rPr lang="zh-CN" altLang="en-US" sz="2400" dirty="0">
-                <a:latin typeface="Arial" panose="020B0604020202020204" pitchFamily="34" charset="0"/>
-                <a:ea typeface="GillSans" panose="020B0502020104020203" pitchFamily="34" charset="-79"/>
-              </a:rPr>
-              <a:t> </a:t>
-            </a:r>
-            <a:r>
-              <a:rPr lang="zh-CN" altLang="zh-CN" sz="2400" b="1" dirty="0">
-                <a:latin typeface="Arial" panose="020B0604020202020204" pitchFamily="34" charset="0"/>
-                <a:ea typeface="GillSans" panose="020B0502020104020203" pitchFamily="34" charset="-79"/>
-              </a:rPr>
-              <a:t>infrequently</a:t>
-            </a:r>
-            <a:r>
-              <a:rPr lang="zh-CN" altLang="zh-CN" sz="2400" dirty="0">
-                <a:latin typeface="Arial" panose="020B0604020202020204" pitchFamily="34" charset="0"/>
-                <a:ea typeface="GillSans" panose="020B0502020104020203" pitchFamily="34" charset="-79"/>
-              </a:rPr>
-              <a:t>.</a:t>
-            </a:r>
-            <a:r>
-              <a:rPr lang="zh-CN" altLang="en-US" sz="2400" dirty="0">
-                <a:latin typeface="Arial" panose="020B0604020202020204" pitchFamily="34" charset="0"/>
-                <a:ea typeface="GillSans" panose="020B0502020104020203" pitchFamily="34" charset="-79"/>
-              </a:rPr>
-              <a:t> </a:t>
-            </a:r>
-            <a:r>
-              <a:rPr lang="zh-CN" altLang="zh-CN" sz="2400" dirty="0">
-                <a:latin typeface="Arial" panose="020B0604020202020204" pitchFamily="34" charset="0"/>
-                <a:ea typeface="GillSans" panose="020B0502020104020203" pitchFamily="34" charset="-79"/>
-              </a:rPr>
-              <a:t>Would a NACK-only protocol be preferable to a protocol that uses ACKs? Why? </a:t>
-            </a:r>
-            <a:endParaRPr lang="zh-CN" altLang="zh-CN" sz="1600" dirty="0">
-              <a:latin typeface="Arial" panose="020B0604020202020204" pitchFamily="34" charset="0"/>
-            </a:endParaRPr>
-          </a:p>
-          <a:p>
-            <a:r>
-              <a:rPr lang="en-US" altLang="zh-CN" dirty="0"/>
-              <a:t>ACK: send ACK upon packet arrival </a:t>
-            </a:r>
-            <a:endParaRPr lang="en-US" altLang="zh-CN" sz="2400" dirty="0"/>
-          </a:p>
-          <a:p>
-            <a:r>
-              <a:rPr lang="en-US" altLang="zh-CN" dirty="0"/>
-              <a:t>NACK: send NACK upon packet loss </a:t>
-            </a:r>
-            <a:endParaRPr lang="en-US" altLang="zh-CN" sz="2400" dirty="0"/>
-          </a:p>
-        </p:txBody>
-      </p:sp>
-      <p:sp>
-        <p:nvSpPr>
-          <p:cNvPr id="6" name="文本框 5">
-            <a:extLst>
-              <a:ext uri="{FF2B5EF4-FFF2-40B4-BE49-F238E27FC236}">
-                <a16:creationId xmlns:a16="http://schemas.microsoft.com/office/drawing/2014/main" id="{08F45C83-B996-874C-9934-BB323100CCA8}"/>
-              </a:ext>
-            </a:extLst>
-          </p:cNvPr>
-          <p:cNvSpPr txBox="1"/>
-          <p:nvPr/>
-        </p:nvSpPr>
-        <p:spPr>
-          <a:xfrm>
-            <a:off x="838200" y="4488497"/>
-            <a:ext cx="10071100" cy="1323439"/>
-          </a:xfrm>
-          <a:prstGeom prst="rect">
-            <a:avLst/>
-          </a:prstGeom>
-          <a:noFill/>
-        </p:spPr>
-        <p:txBody>
-          <a:bodyPr wrap="square" rtlCol="0">
-            <a:spAutoFit/>
-          </a:bodyPr>
-          <a:lstStyle/>
-          <a:p>
-            <a:pPr lvl="0" eaLnBrk="0" fontAlgn="base" hangingPunct="0">
-              <a:spcBef>
-                <a:spcPct val="0"/>
-              </a:spcBef>
-              <a:spcAft>
-                <a:spcPct val="0"/>
-              </a:spcAft>
-            </a:pPr>
-            <a:r>
-              <a:rPr lang="zh-CN" altLang="zh-CN" sz="2000" b="1" dirty="0">
-                <a:solidFill>
-                  <a:srgbClr val="B71E1E"/>
-                </a:solidFill>
-                <a:latin typeface="Arial" panose="020B0604020202020204" pitchFamily="34" charset="0"/>
-                <a:ea typeface="Calibri" panose="020F0502020204030204" pitchFamily="34" charset="0"/>
-              </a:rPr>
-              <a:t>No. In a NAK only protocol, the loss of packet x is only detected by the receiver when packet x+1 is received. If there is a long delay between the transmission of x and the transmission of x+1, then it will be a long time until x can be recovered, under a NAK only protocol </a:t>
-            </a:r>
-            <a:endParaRPr lang="zh-CN" altLang="zh-CN" sz="900" dirty="0">
-              <a:latin typeface="Arial" panose="020B0604020202020204" pitchFamily="34" charset="0"/>
-            </a:endParaRPr>
-          </a:p>
-        </p:txBody>
-      </p:sp>
-    </p:spTree>
-    <p:extLst>
-      <p:ext uri="{BB962C8B-B14F-4D97-AF65-F5344CB8AC3E}">
-        <p14:creationId xmlns:p14="http://schemas.microsoft.com/office/powerpoint/2010/main" val="4278079293"/>
-      </p:ext>
-    </p:extLst>
-  </p:cSld>
-  <p:clrMapOvr>
-    <a:masterClrMapping/>
-  </p:clrMapOvr>
-  <p:timing>
-    <p:tnLst>
-      <p:par>
-        <p:cTn id="1" dur="indefinite" restart="never" nodeType="tmRoot">
-          <p:childTnLst>
-            <p:seq concurrent="1" nextAc="seek">
-              <p:cTn id="2" dur="indefinite" nodeType="mainSeq">
-                <p:childTnLst>
-                  <p:par>
-                    <p:cTn id="3" fill="hold">
-                      <p:stCondLst>
-                        <p:cond delay="indefinite"/>
-                      </p:stCondLst>
-                      <p:childTnLst>
-                        <p:par>
-                          <p:cTn id="4" fill="hold">
-                            <p:stCondLst>
-                              <p:cond delay="0"/>
-                            </p:stCondLst>
-                            <p:childTnLst>
-                              <p:par>
-                                <p:cTn id="5" presetID="1" presetClass="entr" presetSubtype="0" fill="hold" grpId="0" nodeType="clickEffect">
-                                  <p:stCondLst>
-                                    <p:cond delay="0"/>
-                                  </p:stCondLst>
-                                  <p:childTnLst>
-                                    <p:set>
-                                      <p:cBhvr>
-                                        <p:cTn id="6" dur="1" fill="hold">
-                                          <p:stCondLst>
-                                            <p:cond delay="0"/>
-                                          </p:stCondLst>
-                                        </p:cTn>
-                                        <p:tgtEl>
-                                          <p:spTgt spid="6"/>
-                                        </p:tgtEl>
-                                        <p:attrNameLst>
-                                          <p:attrName>style.visibility</p:attrName>
-                                        </p:attrNameLst>
-                                      </p:cBhvr>
-                                      <p:to>
-                                        <p:strVal val="visible"/>
-                                      </p:to>
-                                    </p:set>
-                                  </p:childTnLst>
-                                </p:cTn>
-                              </p:par>
-                            </p:childTnLst>
-                          </p:cTn>
-                        </p:par>
-                      </p:childTnLst>
-                    </p:cTn>
-                  </p:par>
-                </p:childTnLst>
-              </p:cTn>
-              <p:prevCondLst>
-                <p:cond evt="onPrev" delay="0">
-                  <p:tgtEl>
-                    <p:sldTgt/>
-                  </p:tgtEl>
-                </p:cond>
-              </p:prevCondLst>
-              <p:nextCondLst>
-                <p:cond evt="onNext" delay="0">
-                  <p:tgtEl>
-                    <p:sldTgt/>
-                  </p:tgtEl>
-                </p:cond>
-              </p:nextCondLst>
-            </p:seq>
-          </p:childTnLst>
-        </p:cTn>
-      </p:par>
-    </p:tnLst>
-    <p:bldLst>
-      <p:bldP spid="6" grpId="0"/>
-    </p:bldLst>
-  </p:timing>
-</p:sld>
-</file>
-
-<file path=ppt/slides/slide26.xml><?xml version="1.0" encoding="utf-8"?>
-<p:sld xmlns:a="http://schemas.openxmlformats.org/drawingml/2006/main" xmlns:r="http://schemas.openxmlformats.org/officeDocument/2006/relationships" xmlns:p="http://schemas.openxmlformats.org/presentationml/2006/main">
-  <p:cSld>
-    <p:spTree>
-      <p:nvGrpSpPr>
-        <p:cNvPr id="1" name=""/>
-        <p:cNvGrpSpPr/>
-        <p:nvPr/>
-      </p:nvGrpSpPr>
-      <p:grpSpPr>
-        <a:xfrm>
-          <a:off x="0" y="0"/>
-          <a:ext cx="0" cy="0"/>
-          <a:chOff x="0" y="0"/>
-          <a:chExt cx="0" cy="0"/>
-        </a:xfrm>
-      </p:grpSpPr>
-      <p:sp>
-        <p:nvSpPr>
-          <p:cNvPr id="2" name="Title 1">
-            <a:extLst>
-              <a:ext uri="{FF2B5EF4-FFF2-40B4-BE49-F238E27FC236}">
-                <a16:creationId xmlns:a16="http://schemas.microsoft.com/office/drawing/2014/main" id="{45C79BA1-37A3-5741-B0A1-E64646E4283C}"/>
-              </a:ext>
-            </a:extLst>
-          </p:cNvPr>
-          <p:cNvSpPr>
-            <a:spLocks noGrp="1"/>
-          </p:cNvSpPr>
-          <p:nvPr>
-            <p:ph type="title"/>
-          </p:nvPr>
-        </p:nvSpPr>
-        <p:spPr/>
-        <p:txBody>
-          <a:bodyPr/>
-          <a:lstStyle/>
-          <a:p>
-            <a:r>
-              <a:rPr lang="en-US" altLang="zh-CN" b="1" dirty="0"/>
-              <a:t>Exercise</a:t>
-            </a:r>
-            <a:r>
-              <a:rPr lang="zh-CN" altLang="en-US" b="1" dirty="0"/>
-              <a:t> </a:t>
-            </a:r>
-            <a:r>
-              <a:rPr lang="en-US" b="1" dirty="0"/>
-              <a:t>– Q</a:t>
-            </a:r>
-            <a:r>
-              <a:rPr lang="en-US" altLang="zh-CN" b="1" dirty="0"/>
-              <a:t>5</a:t>
-            </a:r>
-            <a:r>
-              <a:rPr lang="zh-CN" altLang="en-US" b="1" dirty="0"/>
-              <a:t> </a:t>
-            </a:r>
-            <a:r>
-              <a:rPr lang="en-US" altLang="zh-CN" b="1" dirty="0"/>
-              <a:t>(N)ACK</a:t>
-            </a:r>
-            <a:endParaRPr lang="en-US" b="1" dirty="0"/>
-          </a:p>
-        </p:txBody>
-      </p:sp>
-      <p:sp>
-        <p:nvSpPr>
-          <p:cNvPr id="4" name="内容占位符 3">
-            <a:extLst>
-              <a:ext uri="{FF2B5EF4-FFF2-40B4-BE49-F238E27FC236}">
-                <a16:creationId xmlns:a16="http://schemas.microsoft.com/office/drawing/2014/main" id="{A80EDC20-98DD-BA46-AF7A-3056F37B7874}"/>
-              </a:ext>
-            </a:extLst>
-          </p:cNvPr>
-          <p:cNvSpPr>
-            <a:spLocks noGrp="1"/>
-          </p:cNvSpPr>
-          <p:nvPr>
-            <p:ph idx="1"/>
-          </p:nvPr>
-        </p:nvSpPr>
-        <p:spPr>
-          <a:xfrm>
-            <a:off x="838200" y="1520825"/>
-            <a:ext cx="10515600" cy="2517775"/>
-          </a:xfrm>
-        </p:spPr>
-        <p:txBody>
-          <a:bodyPr>
-            <a:normAutofit/>
-          </a:bodyPr>
-          <a:lstStyle/>
-          <a:p>
-            <a:pPr marL="0" lvl="0" indent="0" eaLnBrk="0" fontAlgn="base" hangingPunct="0">
-              <a:lnSpc>
-                <a:spcPct val="100000"/>
-              </a:lnSpc>
-              <a:spcBef>
-                <a:spcPct val="0"/>
-              </a:spcBef>
-              <a:spcAft>
-                <a:spcPct val="0"/>
-              </a:spcAft>
-              <a:buNone/>
-            </a:pPr>
-            <a:r>
-              <a:rPr lang="zh-CN" altLang="zh-CN" sz="2400" dirty="0">
-                <a:latin typeface="Arial" panose="020B0604020202020204" pitchFamily="34" charset="0"/>
-                <a:ea typeface="GillSans" panose="020B0502020104020203" pitchFamily="34" charset="-79"/>
-              </a:rPr>
-              <a:t>Now suppose the sender has </a:t>
-            </a:r>
-            <a:r>
-              <a:rPr lang="zh-CN" altLang="zh-CN" sz="2400" b="1" dirty="0">
-                <a:latin typeface="Arial" panose="020B0604020202020204" pitchFamily="34" charset="0"/>
-                <a:ea typeface="GillSans" panose="020B0502020104020203" pitchFamily="34" charset="-79"/>
-              </a:rPr>
-              <a:t>a lot of </a:t>
-            </a:r>
-            <a:r>
-              <a:rPr lang="zh-CN" altLang="zh-CN" sz="2400" dirty="0">
-                <a:latin typeface="Arial" panose="020B0604020202020204" pitchFamily="34" charset="0"/>
-                <a:ea typeface="GillSans" panose="020B0502020104020203" pitchFamily="34" charset="-79"/>
-              </a:rPr>
-              <a:t>data to send and the end-to-end connection experiences few losses. In this second case, would a NACK-only protocol be preferable to a protocol that uses ACKs? Why? (Assuming ACK/NACK is never lost) </a:t>
-            </a:r>
-            <a:endParaRPr lang="en-US" altLang="zh-CN" sz="2400" dirty="0">
-              <a:latin typeface="Arial" panose="020B0604020202020204" pitchFamily="34" charset="0"/>
-              <a:ea typeface="GillSans" panose="020B0502020104020203" pitchFamily="34" charset="-79"/>
-            </a:endParaRPr>
-          </a:p>
-          <a:p>
-            <a:pPr marL="0" lvl="0" indent="0" eaLnBrk="0" fontAlgn="base" hangingPunct="0">
-              <a:lnSpc>
-                <a:spcPct val="100000"/>
-              </a:lnSpc>
-              <a:spcBef>
-                <a:spcPct val="0"/>
-              </a:spcBef>
-              <a:spcAft>
-                <a:spcPct val="0"/>
-              </a:spcAft>
-              <a:buNone/>
-            </a:pPr>
-            <a:endParaRPr lang="zh-CN" altLang="zh-CN" sz="1000" dirty="0">
-              <a:latin typeface="Arial" panose="020B0604020202020204" pitchFamily="34" charset="0"/>
-            </a:endParaRPr>
-          </a:p>
-          <a:p>
-            <a:pPr marL="0" lvl="0" indent="0" eaLnBrk="0" fontAlgn="base" hangingPunct="0">
-              <a:lnSpc>
-                <a:spcPct val="100000"/>
-              </a:lnSpc>
-              <a:spcBef>
-                <a:spcPct val="0"/>
-              </a:spcBef>
-              <a:spcAft>
-                <a:spcPct val="0"/>
-              </a:spcAft>
-              <a:buFontTx/>
-              <a:buChar char="•"/>
-            </a:pPr>
-            <a:r>
-              <a:rPr lang="zh-CN" altLang="en-US" sz="2400" dirty="0">
-                <a:latin typeface="Arial" panose="020B0604020202020204" pitchFamily="34" charset="0"/>
-                <a:ea typeface="GillSans" panose="020B0502020104020203" pitchFamily="34" charset="-79"/>
-              </a:rPr>
-              <a:t> </a:t>
-            </a:r>
-            <a:r>
-              <a:rPr lang="zh-CN" altLang="zh-CN" sz="2400" dirty="0">
-                <a:latin typeface="Arial" panose="020B0604020202020204" pitchFamily="34" charset="0"/>
-                <a:ea typeface="GillSans" panose="020B0502020104020203" pitchFamily="34" charset="-79"/>
-              </a:rPr>
-              <a:t>ACK: send ACK upon packet arrival </a:t>
-            </a:r>
-            <a:endParaRPr lang="zh-CN" altLang="zh-CN" sz="1000" dirty="0">
-              <a:latin typeface="Arial" panose="020B0604020202020204" pitchFamily="34" charset="0"/>
-            </a:endParaRPr>
-          </a:p>
-          <a:p>
-            <a:pPr marL="0" lvl="0" indent="0" eaLnBrk="0" fontAlgn="base" hangingPunct="0">
-              <a:lnSpc>
-                <a:spcPct val="100000"/>
-              </a:lnSpc>
-              <a:spcBef>
-                <a:spcPct val="0"/>
-              </a:spcBef>
-              <a:spcAft>
-                <a:spcPct val="0"/>
-              </a:spcAft>
-              <a:buFontTx/>
-              <a:buChar char="•"/>
-            </a:pPr>
-            <a:r>
-              <a:rPr lang="zh-CN" altLang="en-US" sz="2400" dirty="0">
-                <a:latin typeface="Arial" panose="020B0604020202020204" pitchFamily="34" charset="0"/>
-                <a:ea typeface="GillSans" panose="020B0502020104020203" pitchFamily="34" charset="-79"/>
-              </a:rPr>
-              <a:t> </a:t>
-            </a:r>
-            <a:r>
-              <a:rPr lang="zh-CN" altLang="zh-CN" sz="2400" dirty="0">
-                <a:latin typeface="Arial" panose="020B0604020202020204" pitchFamily="34" charset="0"/>
-                <a:ea typeface="GillSans" panose="020B0502020104020203" pitchFamily="34" charset="-79"/>
-              </a:rPr>
-              <a:t>NACK: send NACK upon packet loss </a:t>
-            </a:r>
-            <a:endParaRPr lang="zh-CN" altLang="zh-CN" sz="1000" dirty="0">
-              <a:latin typeface="Arial" panose="020B0604020202020204" pitchFamily="34" charset="0"/>
-            </a:endParaRPr>
-          </a:p>
-          <a:p>
-            <a:pPr marL="0" lvl="0" indent="0" eaLnBrk="0" fontAlgn="base" hangingPunct="0">
-              <a:lnSpc>
-                <a:spcPct val="100000"/>
-              </a:lnSpc>
-              <a:spcBef>
-                <a:spcPct val="0"/>
-              </a:spcBef>
-              <a:spcAft>
-                <a:spcPct val="0"/>
-              </a:spcAft>
-              <a:buNone/>
-            </a:pPr>
-            <a:endParaRPr lang="zh-CN" altLang="zh-CN" sz="1800" dirty="0">
-              <a:latin typeface="Arial" panose="020B0604020202020204" pitchFamily="34" charset="0"/>
-            </a:endParaRPr>
-          </a:p>
-        </p:txBody>
-      </p:sp>
-      <p:sp>
-        <p:nvSpPr>
-          <p:cNvPr id="5" name="Rectangle 2">
-            <a:extLst>
-              <a:ext uri="{FF2B5EF4-FFF2-40B4-BE49-F238E27FC236}">
-                <a16:creationId xmlns:a16="http://schemas.microsoft.com/office/drawing/2014/main" id="{D26F908B-914F-004A-9D1F-3306C8569B1A}"/>
-              </a:ext>
-            </a:extLst>
-          </p:cNvPr>
-          <p:cNvSpPr>
-            <a:spLocks noChangeArrowheads="1"/>
-          </p:cNvSpPr>
-          <p:nvPr/>
-        </p:nvSpPr>
-        <p:spPr bwMode="auto">
-          <a:xfrm>
-            <a:off x="0" y="43934"/>
-            <a:ext cx="184731" cy="369332"/>
-          </a:xfrm>
-          <a:prstGeom prst="rect">
-            <a:avLst/>
-          </a:prstGeom>
-          <a:solidFill>
-            <a:srgbClr val="FFFFFF"/>
-          </a:solidFill>
-          <a:ln>
-            <a:noFill/>
-          </a:ln>
-          <a:effectLst/>
-          <a:extLst>
-            <a:ext uri="{91240B29-F687-4F45-9708-019B960494DF}">
-              <a14:hiddenLine xmlns:a14="http://schemas.microsoft.com/office/drawing/2010/main" w="9525">
-                <a:solidFill>
-                  <a:schemeClr val="tx1"/>
-                </a:solidFill>
-                <a:miter lim="800000"/>
-                <a:headEnd/>
-                <a:tailEnd/>
-              </a14:hiddenLine>
-            </a:ext>
-            <a:ext uri="{AF507438-7753-43E0-B8FC-AC1667EBCBE1}">
-              <a14:hiddenEffects xmlns:a14="http://schemas.microsoft.com/office/drawing/2010/main">
-                <a:effectLst>
-                  <a:outerShdw dist="35921" dir="2700000" algn="ctr" rotWithShape="0">
-                    <a:schemeClr val="bg2"/>
-                  </a:outerShdw>
-                </a:effectLst>
-              </a14:hiddenEffects>
-            </a:ext>
-          </a:extLst>
-        </p:spPr>
-        <p:txBody>
-          <a:bodyPr vert="horz" wrap="none" lIns="91440" tIns="45720" rIns="91440" bIns="45720" numCol="1" anchor="ctr" anchorCtr="0" compatLnSpc="1">
-            <a:prstTxWarp prst="textNoShape">
-              <a:avLst/>
-            </a:prstTxWarp>
-            <a:spAutoFit/>
-          </a:bodyPr>
-          <a:lstStyle/>
-          <a:p>
-            <a:pPr marL="0" marR="0" lvl="0" indent="0" algn="l" defTabSz="914400" rtl="0" eaLnBrk="0" fontAlgn="base" latinLnBrk="0" hangingPunct="0">
-              <a:lnSpc>
-                <a:spcPct val="100000"/>
-              </a:lnSpc>
-              <a:spcBef>
-                <a:spcPct val="0"/>
-              </a:spcBef>
-              <a:spcAft>
-                <a:spcPct val="0"/>
-              </a:spcAft>
-              <a:buClrTx/>
-              <a:buSzTx/>
-              <a:buFontTx/>
-              <a:buNone/>
-              <a:tabLst/>
-            </a:pPr>
-            <a:endParaRPr kumimoji="0" lang="zh-CN" altLang="zh-CN" sz="1800" b="0" i="0" u="none" strike="noStrike" cap="none" normalizeH="0" baseline="0" dirty="0">
-              <a:ln>
-                <a:noFill/>
-              </a:ln>
-              <a:solidFill>
-                <a:schemeClr val="tx1"/>
-              </a:solidFill>
-              <a:effectLst/>
-              <a:latin typeface="Arial" panose="020B0604020202020204" pitchFamily="34" charset="0"/>
-            </a:endParaRPr>
-          </a:p>
-        </p:txBody>
-      </p:sp>
-      <p:sp>
-        <p:nvSpPr>
-          <p:cNvPr id="9" name="文本框 8">
-            <a:extLst>
-              <a:ext uri="{FF2B5EF4-FFF2-40B4-BE49-F238E27FC236}">
-                <a16:creationId xmlns:a16="http://schemas.microsoft.com/office/drawing/2014/main" id="{A28103B9-27EC-3348-9F0B-6171CD320AA2}"/>
-              </a:ext>
-            </a:extLst>
-          </p:cNvPr>
-          <p:cNvSpPr txBox="1"/>
-          <p:nvPr/>
-        </p:nvSpPr>
-        <p:spPr>
-          <a:xfrm>
-            <a:off x="838200" y="4579937"/>
-            <a:ext cx="9182100" cy="1015663"/>
-          </a:xfrm>
-          <a:prstGeom prst="rect">
-            <a:avLst/>
-          </a:prstGeom>
-          <a:noFill/>
-        </p:spPr>
-        <p:txBody>
-          <a:bodyPr wrap="square" rtlCol="0">
-            <a:spAutoFit/>
-          </a:bodyPr>
-          <a:lstStyle/>
-          <a:p>
-            <a:pPr lvl="0" eaLnBrk="0" fontAlgn="base" hangingPunct="0">
-              <a:spcBef>
-                <a:spcPct val="0"/>
-              </a:spcBef>
-              <a:spcAft>
-                <a:spcPct val="0"/>
-              </a:spcAft>
-            </a:pPr>
-            <a:r>
-              <a:rPr lang="zh-CN" altLang="zh-CN" sz="2000" b="1" dirty="0">
-                <a:solidFill>
-                  <a:srgbClr val="B71E1E"/>
-                </a:solidFill>
-                <a:latin typeface="Arial" panose="020B0604020202020204" pitchFamily="34" charset="0"/>
-                <a:ea typeface="Calibri" panose="020F0502020204030204" pitchFamily="34" charset="0"/>
-              </a:rPr>
-              <a:t>Yes. If data is being sent often, then recovery under a NAK</a:t>
-            </a:r>
-            <a:r>
-              <a:rPr lang="en-US" altLang="zh-CN" sz="2000" b="1">
-                <a:solidFill>
-                  <a:srgbClr val="B71E1E"/>
-                </a:solidFill>
-                <a:latin typeface="Arial" panose="020B0604020202020204" pitchFamily="34" charset="0"/>
-                <a:ea typeface="Calibri" panose="020F0502020204030204" pitchFamily="34" charset="0"/>
-              </a:rPr>
-              <a:t>-</a:t>
-            </a:r>
-            <a:r>
-              <a:rPr lang="zh-CN" altLang="zh-CN" sz="2000" b="1">
-                <a:solidFill>
-                  <a:srgbClr val="B71E1E"/>
-                </a:solidFill>
-                <a:latin typeface="Arial" panose="020B0604020202020204" pitchFamily="34" charset="0"/>
-                <a:ea typeface="Calibri" panose="020F0502020204030204" pitchFamily="34" charset="0"/>
-              </a:rPr>
-              <a:t>only </a:t>
-            </a:r>
-            <a:r>
-              <a:rPr lang="zh-CN" altLang="zh-CN" sz="2000" b="1" dirty="0">
-                <a:solidFill>
-                  <a:srgbClr val="B71E1E"/>
-                </a:solidFill>
-                <a:latin typeface="Arial" panose="020B0604020202020204" pitchFamily="34" charset="0"/>
-                <a:ea typeface="Calibri" panose="020F0502020204030204" pitchFamily="34" charset="0"/>
-              </a:rPr>
-              <a:t>scheme could happen quickly. Moreover, if errors are infrequent, then NAKs are only occasionally sent (when needed). </a:t>
-            </a:r>
-            <a:endParaRPr lang="zh-CN" altLang="zh-CN" sz="900" dirty="0">
-              <a:latin typeface="Arial" panose="020B0604020202020204" pitchFamily="34" charset="0"/>
-            </a:endParaRPr>
-          </a:p>
-        </p:txBody>
-      </p:sp>
-    </p:spTree>
-    <p:extLst>
-      <p:ext uri="{BB962C8B-B14F-4D97-AF65-F5344CB8AC3E}">
-        <p14:creationId xmlns:p14="http://schemas.microsoft.com/office/powerpoint/2010/main" val="3882663473"/>
-      </p:ext>
-    </p:extLst>
-  </p:cSld>
-  <p:clrMapOvr>
-    <a:masterClrMapping/>
-  </p:clrMapOvr>
-  <p:timing>
-    <p:tnLst>
-      <p:par>
-        <p:cTn id="1" dur="indefinite" restart="never" nodeType="tmRoot">
-          <p:childTnLst>
-            <p:seq concurrent="1" nextAc="seek">
-              <p:cTn id="2" dur="indefinite" nodeType="mainSeq">
-                <p:childTnLst>
-                  <p:par>
-                    <p:cTn id="3" fill="hold">
-                      <p:stCondLst>
-                        <p:cond delay="indefinite"/>
-                      </p:stCondLst>
-                      <p:childTnLst>
-                        <p:par>
-                          <p:cTn id="4" fill="hold">
-                            <p:stCondLst>
-                              <p:cond delay="0"/>
-                            </p:stCondLst>
-                            <p:childTnLst>
-                              <p:par>
-                                <p:cTn id="5" presetID="1" presetClass="entr" presetSubtype="0" fill="hold" grpId="0" nodeType="clickEffect">
-                                  <p:stCondLst>
-                                    <p:cond delay="0"/>
-                                  </p:stCondLst>
-                                  <p:childTnLst>
-                                    <p:set>
-                                      <p:cBhvr>
-                                        <p:cTn id="6" dur="1" fill="hold">
-                                          <p:stCondLst>
-                                            <p:cond delay="0"/>
-                                          </p:stCondLst>
-                                        </p:cTn>
-                                        <p:tgtEl>
-                                          <p:spTgt spid="9"/>
-                                        </p:tgtEl>
-                                        <p:attrNameLst>
-                                          <p:attrName>style.visibility</p:attrName>
-                                        </p:attrNameLst>
-                                      </p:cBhvr>
-                                      <p:to>
-                                        <p:strVal val="visible"/>
-                                      </p:to>
-                                    </p:set>
-                                  </p:childTnLst>
-                                </p:cTn>
-                              </p:par>
-                            </p:childTnLst>
-                          </p:cTn>
-                        </p:par>
-                      </p:childTnLst>
-                    </p:cTn>
-                  </p:par>
-                </p:childTnLst>
-              </p:cTn>
-              <p:prevCondLst>
-                <p:cond evt="onPrev" delay="0">
-                  <p:tgtEl>
-                    <p:sldTgt/>
-                  </p:tgtEl>
-                </p:cond>
-              </p:prevCondLst>
-              <p:nextCondLst>
-                <p:cond evt="onNext" delay="0">
-                  <p:tgtEl>
-                    <p:sldTgt/>
-                  </p:tgtEl>
-                </p:cond>
-              </p:nextCondLst>
-            </p:seq>
-          </p:childTnLst>
-        </p:cTn>
-      </p:par>
-    </p:tnLst>
-    <p:bldLst>
-      <p:bldP spid="9" grpId="0"/>
-    </p:bldLst>
-  </p:timing>
-</p:sld>
-</file>
-
-<file path=ppt/slides/slide27.xml><?xml version="1.0" encoding="utf-8"?>
-<p:sld xmlns:a="http://schemas.openxmlformats.org/drawingml/2006/main" xmlns:r="http://schemas.openxmlformats.org/officeDocument/2006/relationships" xmlns:p="http://schemas.openxmlformats.org/presentationml/2006/main">
-  <p:cSld>
-    <p:spTree>
-      <p:nvGrpSpPr>
-        <p:cNvPr id="1" name=""/>
-        <p:cNvGrpSpPr/>
-        <p:nvPr/>
-      </p:nvGrpSpPr>
-      <p:grpSpPr>
-        <a:xfrm>
-          <a:off x="0" y="0"/>
-          <a:ext cx="0" cy="0"/>
-          <a:chOff x="0" y="0"/>
-          <a:chExt cx="0" cy="0"/>
-        </a:xfrm>
-      </p:grpSpPr>
-      <p:sp>
-        <p:nvSpPr>
           <p:cNvPr id="2" name="Title 1">
             <a:extLst>
               <a:ext uri="{FF2B5EF4-FFF2-40B4-BE49-F238E27FC236}">
@@ -9863,7 +9003,7 @@
 </p:sld>
 </file>
 
-<file path=ppt/slides/slide3.xml><?xml version="1.0" encoding="utf-8"?>
+<file path=ppt/slides/slide25.xml><?xml version="1.0" encoding="utf-8"?>
 <p:sld xmlns:a="http://schemas.openxmlformats.org/drawingml/2006/main" xmlns:r="http://schemas.openxmlformats.org/officeDocument/2006/relationships" xmlns:p="http://schemas.openxmlformats.org/presentationml/2006/main">
   <p:cSld>
     <p:spTree>
@@ -9882,62 +9022,42 @@
       </p:grpSpPr>
       <p:sp>
         <p:nvSpPr>
-          <p:cNvPr id="2" name="标题 1">
-            <a:extLst>
-              <a:ext uri="{FF2B5EF4-FFF2-40B4-BE49-F238E27FC236}">
-                <a16:creationId xmlns:a16="http://schemas.microsoft.com/office/drawing/2014/main" id="{413607AE-4FC0-ED15-C06D-0D33B6211925}"/>
-              </a:ext>
-            </a:extLst>
-          </p:cNvPr>
-          <p:cNvSpPr>
-            <a:spLocks noGrp="1"/>
-          </p:cNvSpPr>
-          <p:nvPr>
-            <p:ph type="ctrTitle"/>
-          </p:nvPr>
-        </p:nvSpPr>
-        <p:spPr/>
-        <p:txBody>
-          <a:bodyPr/>
-          <a:lstStyle/>
-          <a:p>
-            <a:r>
-              <a:rPr kumimoji="1" lang="en-US" altLang="zh-CN" b="1" dirty="0"/>
-              <a:t>Video Streaming</a:t>
-            </a:r>
-            <a:endParaRPr kumimoji="1" lang="zh-CN" altLang="en-US" b="1" dirty="0"/>
-          </a:p>
-        </p:txBody>
-      </p:sp>
-      <p:sp>
-        <p:nvSpPr>
-          <p:cNvPr id="3" name="副标题 2">
-            <a:extLst>
-              <a:ext uri="{FF2B5EF4-FFF2-40B4-BE49-F238E27FC236}">
-                <a16:creationId xmlns:a16="http://schemas.microsoft.com/office/drawing/2014/main" id="{E15F643D-5A8C-1570-8C8E-13C68855E292}"/>
-              </a:ext>
-            </a:extLst>
-          </p:cNvPr>
-          <p:cNvSpPr>
-            <a:spLocks noGrp="1"/>
-          </p:cNvSpPr>
-          <p:nvPr>
-            <p:ph type="subTitle" idx="1"/>
-          </p:nvPr>
-        </p:nvSpPr>
-        <p:spPr/>
-        <p:txBody>
-          <a:bodyPr/>
-          <a:lstStyle/>
-          <a:p>
-            <a:endParaRPr kumimoji="1" lang="zh-CN" altLang="en-US"/>
+          <p:cNvPr id="4" name="Rectangle 3">
+            <a:extLst>
+              <a:ext uri="{FF2B5EF4-FFF2-40B4-BE49-F238E27FC236}">
+                <a16:creationId xmlns:a16="http://schemas.microsoft.com/office/drawing/2014/main" id="{A8D2CAE8-E323-A14E-A62F-188A25405FEA}"/>
+              </a:ext>
+            </a:extLst>
+          </p:cNvPr>
+          <p:cNvSpPr/>
+          <p:nvPr/>
+        </p:nvSpPr>
+        <p:spPr>
+          <a:xfrm>
+            <a:off x="5432260" y="3167390"/>
+            <a:ext cx="1651927" cy="646331"/>
+          </a:xfrm>
+          <a:prstGeom prst="rect">
+            <a:avLst/>
+          </a:prstGeom>
+        </p:spPr>
+        <p:txBody>
+          <a:bodyPr wrap="none">
+            <a:spAutoFit/>
+          </a:bodyPr>
+          <a:lstStyle/>
+          <a:p>
+            <a:r>
+              <a:rPr lang="en-US" sz="3600" dirty="0"/>
+              <a:t>Thanks!</a:t>
+            </a:r>
           </a:p>
         </p:txBody>
       </p:sp>
     </p:spTree>
     <p:extLst>
       <p:ext uri="{BB962C8B-B14F-4D97-AF65-F5344CB8AC3E}">
-        <p14:creationId xmlns:p14="http://schemas.microsoft.com/office/powerpoint/2010/main" val="223323704"/>
+        <p14:creationId xmlns:p14="http://schemas.microsoft.com/office/powerpoint/2010/main" val="3216618933"/>
       </p:ext>
     </p:extLst>
   </p:cSld>
@@ -9947,7 +9067,7 @@
 </p:sld>
 </file>
 
-<file path=ppt/slides/slide4.xml><?xml version="1.0" encoding="utf-8"?>
+<file path=ppt/slides/slide26.xml><?xml version="1.0" encoding="utf-8"?>
 <p:sld xmlns:a="http://schemas.openxmlformats.org/drawingml/2006/main" xmlns:r="http://schemas.openxmlformats.org/officeDocument/2006/relationships" xmlns:p="http://schemas.openxmlformats.org/presentationml/2006/main">
   <p:cSld>
     <p:spTree>
@@ -9995,7 +9115,11 @@
             </a:r>
             <a:r>
               <a:rPr lang="en-US" b="1" dirty="0"/>
-              <a:t>- Q1</a:t>
+              <a:t>– Q</a:t>
+            </a:r>
+            <a:r>
+              <a:rPr lang="en-US" altLang="zh-CN" b="1" dirty="0"/>
+              <a:t>4</a:t>
             </a:r>
             <a:r>
               <a:rPr lang="zh-CN" altLang="en-US" b="1" dirty="0"/>
@@ -10003,15 +9127,7 @@
             </a:r>
             <a:r>
               <a:rPr lang="en-US" altLang="zh-CN" b="1" dirty="0"/>
-              <a:t>HTTP</a:t>
-            </a:r>
-            <a:r>
-              <a:rPr lang="zh-CN" altLang="en-US" b="1" dirty="0"/>
-              <a:t> </a:t>
-            </a:r>
-            <a:r>
-              <a:rPr lang="en-US" altLang="zh-CN" b="1" dirty="0"/>
-              <a:t>Streaming</a:t>
+              <a:t>(N)ACK</a:t>
             </a:r>
             <a:endParaRPr lang="en-US" b="1" dirty="0"/>
           </a:p>
@@ -10035,13 +9151,13 @@
         </p:nvSpPr>
         <p:spPr>
           <a:xfrm>
-            <a:off x="838200" y="1632427"/>
-            <a:ext cx="10515600" cy="2705735"/>
+            <a:off x="838200" y="1571625"/>
+            <a:ext cx="10071100" cy="2705735"/>
           </a:xfrm>
         </p:spPr>
         <p:txBody>
           <a:bodyPr>
-            <a:normAutofit fontScale="77500" lnSpcReduction="20000"/>
+            <a:normAutofit/>
           </a:bodyPr>
           <a:lstStyle/>
           <a:p>
@@ -10053,69 +9169,444 @@
                 <a:latin typeface="Arial" panose="020B0604020202020204" pitchFamily="34" charset="0"/>
                 <a:ea typeface="GillSans" panose="020B0502020104020203" pitchFamily="34" charset="-79"/>
               </a:rPr>
-              <a:t>Consider a simple HTTP streaming model.</a:t>
-            </a:r>
-            <a:br>
+              <a:t>Consider a reliable data transfer protocol that uses only negative acknowledgments (NACK). Suppose the sender sends data only</a:t>
+            </a:r>
+            <a:r>
+              <a:rPr lang="zh-CN" altLang="en-US" sz="2400" dirty="0">
+                <a:latin typeface="Arial" panose="020B0604020202020204" pitchFamily="34" charset="0"/>
+                <a:ea typeface="GillSans" panose="020B0502020104020203" pitchFamily="34" charset="-79"/>
+              </a:rPr>
+              <a:t> </a:t>
+            </a:r>
+            <a:r>
+              <a:rPr lang="zh-CN" altLang="zh-CN" sz="2400" b="1" dirty="0">
+                <a:latin typeface="Arial" panose="020B0604020202020204" pitchFamily="34" charset="0"/>
+                <a:ea typeface="GillSans" panose="020B0502020104020203" pitchFamily="34" charset="-79"/>
+              </a:rPr>
+              <a:t>infrequently</a:t>
+            </a:r>
+            <a:r>
               <a:rPr lang="zh-CN" altLang="zh-CN" sz="2400" dirty="0">
                 <a:latin typeface="Arial" panose="020B0604020202020204" pitchFamily="34" charset="0"/>
                 <a:ea typeface="GillSans" panose="020B0502020104020203" pitchFamily="34" charset="-79"/>
               </a:rPr>
-            </a:br>
+              <a:t>.</a:t>
+            </a:r>
+            <a:r>
+              <a:rPr lang="zh-CN" altLang="en-US" sz="2400" dirty="0">
+                <a:latin typeface="Arial" panose="020B0604020202020204" pitchFamily="34" charset="0"/>
+                <a:ea typeface="GillSans" panose="020B0502020104020203" pitchFamily="34" charset="-79"/>
+              </a:rPr>
+              <a:t> </a:t>
+            </a:r>
+            <a:r>
+              <a:rPr lang="zh-CN" altLang="zh-CN" sz="2400" dirty="0">
+                <a:latin typeface="Arial" panose="020B0604020202020204" pitchFamily="34" charset="0"/>
+                <a:ea typeface="GillSans" panose="020B0502020104020203" pitchFamily="34" charset="-79"/>
+              </a:rPr>
+              <a:t>Would a NACK-only protocol be preferable to a protocol that uses ACKs? Why? </a:t>
+            </a:r>
+            <a:endParaRPr lang="zh-CN" altLang="zh-CN" sz="1600" dirty="0">
+              <a:latin typeface="Arial" panose="020B0604020202020204" pitchFamily="34" charset="0"/>
+            </a:endParaRPr>
+          </a:p>
+          <a:p>
+            <a:r>
+              <a:rPr lang="en-US" altLang="zh-CN" dirty="0"/>
+              <a:t>ACK: send ACK upon packet arrival </a:t>
+            </a:r>
+            <a:endParaRPr lang="en-US" altLang="zh-CN" sz="2400" dirty="0"/>
+          </a:p>
+          <a:p>
+            <a:r>
+              <a:rPr lang="en-US" altLang="zh-CN" dirty="0"/>
+              <a:t>NACK: send NACK upon packet loss </a:t>
+            </a:r>
+            <a:endParaRPr lang="en-US" altLang="zh-CN" sz="2400" dirty="0"/>
+          </a:p>
+        </p:txBody>
+      </p:sp>
+      <p:sp>
+        <p:nvSpPr>
+          <p:cNvPr id="6" name="文本框 5">
+            <a:extLst>
+              <a:ext uri="{FF2B5EF4-FFF2-40B4-BE49-F238E27FC236}">
+                <a16:creationId xmlns:a16="http://schemas.microsoft.com/office/drawing/2014/main" id="{08F45C83-B996-874C-9934-BB323100CCA8}"/>
+              </a:ext>
+            </a:extLst>
+          </p:cNvPr>
+          <p:cNvSpPr txBox="1"/>
+          <p:nvPr/>
+        </p:nvSpPr>
+        <p:spPr>
+          <a:xfrm>
+            <a:off x="838200" y="4488497"/>
+            <a:ext cx="10071100" cy="1323439"/>
+          </a:xfrm>
+          <a:prstGeom prst="rect">
+            <a:avLst/>
+          </a:prstGeom>
+          <a:noFill/>
+        </p:spPr>
+        <p:txBody>
+          <a:bodyPr wrap="square" rtlCol="0">
+            <a:spAutoFit/>
+          </a:bodyPr>
+          <a:lstStyle/>
+          <a:p>
+            <a:pPr lvl="0" eaLnBrk="0" fontAlgn="base" hangingPunct="0">
+              <a:spcBef>
+                <a:spcPct val="0"/>
+              </a:spcBef>
+              <a:spcAft>
+                <a:spcPct val="0"/>
+              </a:spcAft>
+            </a:pPr>
+            <a:r>
+              <a:rPr lang="zh-CN" altLang="zh-CN" sz="2000" b="1" dirty="0">
+                <a:solidFill>
+                  <a:srgbClr val="B71E1E"/>
+                </a:solidFill>
+                <a:latin typeface="Arial" panose="020B0604020202020204" pitchFamily="34" charset="0"/>
+                <a:ea typeface="Calibri" panose="020F0502020204030204" pitchFamily="34" charset="0"/>
+              </a:rPr>
+              <a:t>No. In a NAK only protocol, the loss of packet x is only detected by the receiver when packet x+1 is received. If there is a long delay between the transmission of x and the transmission of x+1, then it will be a long time until x can be recovered, under a NAK only protocol </a:t>
+            </a:r>
+            <a:endParaRPr lang="zh-CN" altLang="zh-CN" sz="900" dirty="0">
+              <a:latin typeface="Arial" panose="020B0604020202020204" pitchFamily="34" charset="0"/>
+            </a:endParaRPr>
+          </a:p>
+        </p:txBody>
+      </p:sp>
+    </p:spTree>
+    <p:extLst>
+      <p:ext uri="{BB962C8B-B14F-4D97-AF65-F5344CB8AC3E}">
+        <p14:creationId xmlns:p14="http://schemas.microsoft.com/office/powerpoint/2010/main" val="4278079293"/>
+      </p:ext>
+    </p:extLst>
+  </p:cSld>
+  <p:clrMapOvr>
+    <a:masterClrMapping/>
+  </p:clrMapOvr>
+  <p:timing>
+    <p:tnLst>
+      <p:par>
+        <p:cTn id="1" dur="indefinite" restart="never" nodeType="tmRoot">
+          <p:childTnLst>
+            <p:seq concurrent="1" nextAc="seek">
+              <p:cTn id="2" dur="indefinite" nodeType="mainSeq">
+                <p:childTnLst>
+                  <p:par>
+                    <p:cTn id="3" fill="hold">
+                      <p:stCondLst>
+                        <p:cond delay="indefinite"/>
+                      </p:stCondLst>
+                      <p:childTnLst>
+                        <p:par>
+                          <p:cTn id="4" fill="hold">
+                            <p:stCondLst>
+                              <p:cond delay="0"/>
+                            </p:stCondLst>
+                            <p:childTnLst>
+                              <p:par>
+                                <p:cTn id="5" presetID="1" presetClass="entr" presetSubtype="0" fill="hold" grpId="0" nodeType="clickEffect">
+                                  <p:stCondLst>
+                                    <p:cond delay="0"/>
+                                  </p:stCondLst>
+                                  <p:childTnLst>
+                                    <p:set>
+                                      <p:cBhvr>
+                                        <p:cTn id="6" dur="1" fill="hold">
+                                          <p:stCondLst>
+                                            <p:cond delay="0"/>
+                                          </p:stCondLst>
+                                        </p:cTn>
+                                        <p:tgtEl>
+                                          <p:spTgt spid="6"/>
+                                        </p:tgtEl>
+                                        <p:attrNameLst>
+                                          <p:attrName>style.visibility</p:attrName>
+                                        </p:attrNameLst>
+                                      </p:cBhvr>
+                                      <p:to>
+                                        <p:strVal val="visible"/>
+                                      </p:to>
+                                    </p:set>
+                                  </p:childTnLst>
+                                </p:cTn>
+                              </p:par>
+                            </p:childTnLst>
+                          </p:cTn>
+                        </p:par>
+                      </p:childTnLst>
+                    </p:cTn>
+                  </p:par>
+                </p:childTnLst>
+              </p:cTn>
+              <p:prevCondLst>
+                <p:cond evt="onPrev" delay="0">
+                  <p:tgtEl>
+                    <p:sldTgt/>
+                  </p:tgtEl>
+                </p:cond>
+              </p:prevCondLst>
+              <p:nextCondLst>
+                <p:cond evt="onNext" delay="0">
+                  <p:tgtEl>
+                    <p:sldTgt/>
+                  </p:tgtEl>
+                </p:cond>
+              </p:nextCondLst>
+            </p:seq>
+          </p:childTnLst>
+        </p:cTn>
+      </p:par>
+    </p:tnLst>
+    <p:bldLst>
+      <p:bldP spid="6" grpId="0"/>
+    </p:bldLst>
+  </p:timing>
+</p:sld>
+</file>
+
+<file path=ppt/slides/slide27.xml><?xml version="1.0" encoding="utf-8"?>
+<p:sld xmlns:a="http://schemas.openxmlformats.org/drawingml/2006/main" xmlns:r="http://schemas.openxmlformats.org/officeDocument/2006/relationships" xmlns:p="http://schemas.openxmlformats.org/presentationml/2006/main">
+  <p:cSld>
+    <p:spTree>
+      <p:nvGrpSpPr>
+        <p:cNvPr id="1" name=""/>
+        <p:cNvGrpSpPr/>
+        <p:nvPr/>
+      </p:nvGrpSpPr>
+      <p:grpSpPr>
+        <a:xfrm>
+          <a:off x="0" y="0"/>
+          <a:ext cx="0" cy="0"/>
+          <a:chOff x="0" y="0"/>
+          <a:chExt cx="0" cy="0"/>
+        </a:xfrm>
+      </p:grpSpPr>
+      <p:sp>
+        <p:nvSpPr>
+          <p:cNvPr id="2" name="Title 1">
+            <a:extLst>
+              <a:ext uri="{FF2B5EF4-FFF2-40B4-BE49-F238E27FC236}">
+                <a16:creationId xmlns:a16="http://schemas.microsoft.com/office/drawing/2014/main" id="{45C79BA1-37A3-5741-B0A1-E64646E4283C}"/>
+              </a:ext>
+            </a:extLst>
+          </p:cNvPr>
+          <p:cNvSpPr>
+            <a:spLocks noGrp="1"/>
+          </p:cNvSpPr>
+          <p:nvPr>
+            <p:ph type="title"/>
+          </p:nvPr>
+        </p:nvSpPr>
+        <p:spPr/>
+        <p:txBody>
+          <a:bodyPr/>
+          <a:lstStyle/>
+          <a:p>
+            <a:r>
+              <a:rPr lang="en-US" altLang="zh-CN" b="1" dirty="0"/>
+              <a:t>Exercise</a:t>
+            </a:r>
+            <a:r>
+              <a:rPr lang="zh-CN" altLang="en-US" b="1" dirty="0"/>
+              <a:t> </a:t>
+            </a:r>
+            <a:r>
+              <a:rPr lang="en-US" b="1" dirty="0"/>
+              <a:t>– Q</a:t>
+            </a:r>
+            <a:r>
+              <a:rPr lang="en-US" altLang="zh-CN" b="1" dirty="0"/>
+              <a:t>5</a:t>
+            </a:r>
+            <a:r>
+              <a:rPr lang="zh-CN" altLang="en-US" b="1" dirty="0"/>
+              <a:t> </a:t>
+            </a:r>
+            <a:r>
+              <a:rPr lang="en-US" altLang="zh-CN" b="1" dirty="0"/>
+              <a:t>(N)ACK</a:t>
+            </a:r>
+            <a:endParaRPr lang="en-US" b="1" dirty="0"/>
+          </a:p>
+        </p:txBody>
+      </p:sp>
+      <p:sp>
+        <p:nvSpPr>
+          <p:cNvPr id="4" name="内容占位符 3">
+            <a:extLst>
+              <a:ext uri="{FF2B5EF4-FFF2-40B4-BE49-F238E27FC236}">
+                <a16:creationId xmlns:a16="http://schemas.microsoft.com/office/drawing/2014/main" id="{A80EDC20-98DD-BA46-AF7A-3056F37B7874}"/>
+              </a:ext>
+            </a:extLst>
+          </p:cNvPr>
+          <p:cNvSpPr>
+            <a:spLocks noGrp="1"/>
+          </p:cNvSpPr>
+          <p:nvPr>
+            <p:ph idx="1"/>
+          </p:nvPr>
+        </p:nvSpPr>
+        <p:spPr>
+          <a:xfrm>
+            <a:off x="838200" y="1520825"/>
+            <a:ext cx="10515600" cy="2517775"/>
+          </a:xfrm>
+        </p:spPr>
+        <p:txBody>
+          <a:bodyPr>
+            <a:normAutofit/>
+          </a:bodyPr>
+          <a:lstStyle/>
+          <a:p>
+            <a:pPr marL="0" lvl="0" indent="0" eaLnBrk="0" fontAlgn="base" hangingPunct="0">
+              <a:lnSpc>
+                <a:spcPct val="100000"/>
+              </a:lnSpc>
+              <a:spcBef>
+                <a:spcPct val="0"/>
+              </a:spcBef>
+              <a:spcAft>
+                <a:spcPct val="0"/>
+              </a:spcAft>
+              <a:buNone/>
+            </a:pPr>
+            <a:r>
+              <a:rPr lang="zh-CN" altLang="zh-CN" sz="2400" dirty="0">
+                <a:latin typeface="Arial" panose="020B0604020202020204" pitchFamily="34" charset="0"/>
+                <a:ea typeface="GillSans" panose="020B0502020104020203" pitchFamily="34" charset="-79"/>
+              </a:rPr>
+              <a:t>Now suppose the sender has </a:t>
+            </a:r>
+            <a:r>
+              <a:rPr lang="zh-CN" altLang="zh-CN" sz="2400" b="1" dirty="0">
+                <a:latin typeface="Arial" panose="020B0604020202020204" pitchFamily="34" charset="0"/>
+                <a:ea typeface="GillSans" panose="020B0502020104020203" pitchFamily="34" charset="-79"/>
+              </a:rPr>
+              <a:t>a lot of </a:t>
+            </a:r>
+            <a:r>
+              <a:rPr lang="zh-CN" altLang="zh-CN" sz="2400" dirty="0">
+                <a:latin typeface="Arial" panose="020B0604020202020204" pitchFamily="34" charset="0"/>
+                <a:ea typeface="GillSans" panose="020B0502020104020203" pitchFamily="34" charset="-79"/>
+              </a:rPr>
+              <a:t>data to send and the end-to-end connection experiences few losses. In this second case, would a NACK-only protocol be preferable to a protocol that uses ACKs? Why? (Assuming ACK/NACK is never lost) </a:t>
+            </a:r>
             <a:endParaRPr lang="en-US" altLang="zh-CN" sz="2400" dirty="0">
               <a:latin typeface="Arial" panose="020B0604020202020204" pitchFamily="34" charset="0"/>
               <a:ea typeface="GillSans" panose="020B0502020104020203" pitchFamily="34" charset="-79"/>
             </a:endParaRPr>
           </a:p>
           <a:p>
-            <a:r>
-              <a:rPr lang="en-US" altLang="zh-CN" dirty="0"/>
-              <a:t>𝑄 is the number of bits that must be buffered before the client application begins playout. </a:t>
-            </a:r>
-          </a:p>
-          <a:p>
-            <a:r>
-              <a:rPr lang="en-US" altLang="zh-CN" dirty="0"/>
-              <a:t>𝑟 is the video consumption rate.</a:t>
-            </a:r>
-          </a:p>
-          <a:p>
-            <a:r>
-              <a:rPr lang="en-US" altLang="zh-CN" dirty="0"/>
-              <a:t>𝑥 is the bits sending rate whenever the client buffer is not full. </a:t>
-            </a:r>
-            <a:endParaRPr lang="en-US" altLang="zh-CN" sz="1600" dirty="0"/>
-          </a:p>
-          <a:p>
-            <a:r>
-              <a:rPr lang="en-US" altLang="zh-CN" dirty="0"/>
-              <a:t>Also assume that 𝑥 &lt; 𝑟.</a:t>
-            </a:r>
-          </a:p>
-          <a:p>
-            <a:pPr marL="0" indent="0">
+            <a:pPr marL="0" lvl="0" indent="0" eaLnBrk="0" fontAlgn="base" hangingPunct="0">
+              <a:lnSpc>
+                <a:spcPct val="100000"/>
+              </a:lnSpc>
+              <a:spcBef>
+                <a:spcPct val="0"/>
+              </a:spcBef>
+              <a:spcAft>
+                <a:spcPct val="0"/>
+              </a:spcAft>
               <a:buNone/>
             </a:pPr>
-            <a:br>
-              <a:rPr lang="en-US" altLang="zh-CN" dirty="0"/>
-            </a:br>
-            <a:endParaRPr lang="zh-CN" altLang="zh-CN" sz="1600" dirty="0">
+            <a:endParaRPr lang="zh-CN" altLang="zh-CN" sz="1000" dirty="0">
               <a:latin typeface="Arial" panose="020B0604020202020204" pitchFamily="34" charset="0"/>
             </a:endParaRPr>
           </a:p>
           <a:p>
-            <a:pPr marL="0" indent="0">
+            <a:pPr marL="0" lvl="0" indent="0" eaLnBrk="0" fontAlgn="base" hangingPunct="0">
+              <a:lnSpc>
+                <a:spcPct val="100000"/>
+              </a:lnSpc>
+              <a:spcBef>
+                <a:spcPct val="0"/>
+              </a:spcBef>
+              <a:spcAft>
+                <a:spcPct val="0"/>
+              </a:spcAft>
+              <a:buFontTx/>
+              <a:buChar char="•"/>
+            </a:pPr>
+            <a:r>
+              <a:rPr lang="zh-CN" altLang="en-US" sz="2400" dirty="0">
+                <a:latin typeface="Arial" panose="020B0604020202020204" pitchFamily="34" charset="0"/>
+                <a:ea typeface="GillSans" panose="020B0502020104020203" pitchFamily="34" charset="-79"/>
+              </a:rPr>
+              <a:t> </a:t>
+            </a:r>
+            <a:r>
+              <a:rPr lang="zh-CN" altLang="zh-CN" sz="2400" dirty="0">
+                <a:latin typeface="Arial" panose="020B0604020202020204" pitchFamily="34" charset="0"/>
+                <a:ea typeface="GillSans" panose="020B0502020104020203" pitchFamily="34" charset="-79"/>
+              </a:rPr>
+              <a:t>ACK: send ACK upon packet arrival </a:t>
+            </a:r>
+            <a:endParaRPr lang="zh-CN" altLang="zh-CN" sz="1000" dirty="0">
+              <a:latin typeface="Arial" panose="020B0604020202020204" pitchFamily="34" charset="0"/>
+            </a:endParaRPr>
+          </a:p>
+          <a:p>
+            <a:pPr marL="0" lvl="0" indent="0" eaLnBrk="0" fontAlgn="base" hangingPunct="0">
+              <a:lnSpc>
+                <a:spcPct val="100000"/>
+              </a:lnSpc>
+              <a:spcBef>
+                <a:spcPct val="0"/>
+              </a:spcBef>
+              <a:spcAft>
+                <a:spcPct val="0"/>
+              </a:spcAft>
+              <a:buFontTx/>
+              <a:buChar char="•"/>
+            </a:pPr>
+            <a:r>
+              <a:rPr lang="zh-CN" altLang="en-US" sz="2400" dirty="0">
+                <a:latin typeface="Arial" panose="020B0604020202020204" pitchFamily="34" charset="0"/>
+                <a:ea typeface="GillSans" panose="020B0502020104020203" pitchFamily="34" charset="-79"/>
+              </a:rPr>
+              <a:t> </a:t>
+            </a:r>
+            <a:r>
+              <a:rPr lang="zh-CN" altLang="zh-CN" sz="2400" dirty="0">
+                <a:latin typeface="Arial" panose="020B0604020202020204" pitchFamily="34" charset="0"/>
+                <a:ea typeface="GillSans" panose="020B0502020104020203" pitchFamily="34" charset="-79"/>
+              </a:rPr>
+              <a:t>NACK: send NACK upon packet loss </a:t>
+            </a:r>
+            <a:endParaRPr lang="zh-CN" altLang="zh-CN" sz="1000" dirty="0">
+              <a:latin typeface="Arial" panose="020B0604020202020204" pitchFamily="34" charset="0"/>
+            </a:endParaRPr>
+          </a:p>
+          <a:p>
+            <a:pPr marL="0" lvl="0" indent="0" eaLnBrk="0" fontAlgn="base" hangingPunct="0">
+              <a:lnSpc>
+                <a:spcPct val="100000"/>
+              </a:lnSpc>
+              <a:spcBef>
+                <a:spcPct val="0"/>
+              </a:spcBef>
+              <a:spcAft>
+                <a:spcPct val="0"/>
+              </a:spcAft>
               <a:buNone/>
             </a:pPr>
-            <a:endParaRPr lang="en-US" sz="2400" dirty="0"/>
-          </a:p>
-        </p:txBody>
-      </p:sp>
-      <p:sp>
-        <p:nvSpPr>
-          <p:cNvPr id="4" name="Rectangle 2">
-            <a:extLst>
-              <a:ext uri="{FF2B5EF4-FFF2-40B4-BE49-F238E27FC236}">
-                <a16:creationId xmlns:a16="http://schemas.microsoft.com/office/drawing/2014/main" id="{3A7EC6F6-3A9C-6A4E-9F5B-60AABA1D48A4}"/>
+            <a:endParaRPr lang="zh-CN" altLang="zh-CN" sz="1800" dirty="0">
+              <a:latin typeface="Arial" panose="020B0604020202020204" pitchFamily="34" charset="0"/>
+            </a:endParaRPr>
+          </a:p>
+        </p:txBody>
+      </p:sp>
+      <p:sp>
+        <p:nvSpPr>
+          <p:cNvPr id="5" name="Rectangle 2">
+            <a:extLst>
+              <a:ext uri="{FF2B5EF4-FFF2-40B4-BE49-F238E27FC236}">
+                <a16:creationId xmlns:a16="http://schemas.microsoft.com/office/drawing/2014/main" id="{D26F908B-914F-004A-9D1F-3306C8569B1A}"/>
               </a:ext>
             </a:extLst>
           </p:cNvPr>
@@ -10201,10 +9692,10 @@
       </p:sp>
       <p:sp>
         <p:nvSpPr>
-          <p:cNvPr id="5" name="文本框 4">
-            <a:extLst>
-              <a:ext uri="{FF2B5EF4-FFF2-40B4-BE49-F238E27FC236}">
-                <a16:creationId xmlns:a16="http://schemas.microsoft.com/office/drawing/2014/main" id="{FE188F2A-4142-E048-B3A0-3DF53FF7B70D}"/>
+          <p:cNvPr id="9" name="文本框 8">
+            <a:extLst>
+              <a:ext uri="{FF2B5EF4-FFF2-40B4-BE49-F238E27FC236}">
+                <a16:creationId xmlns:a16="http://schemas.microsoft.com/office/drawing/2014/main" id="{A28103B9-27EC-3348-9F0B-6171CD320AA2}"/>
               </a:ext>
             </a:extLst>
           </p:cNvPr>
@@ -10213,8 +9704,8 @@
         </p:nvSpPr>
         <p:spPr>
           <a:xfrm>
-            <a:off x="838200" y="4279900"/>
-            <a:ext cx="4635500" cy="369332"/>
+            <a:off x="838200" y="4579937"/>
+            <a:ext cx="9182100" cy="1015663"/>
           </a:xfrm>
           <a:prstGeom prst="rect">
             <a:avLst/>
@@ -10227,12 +9718,56 @@
           </a:bodyPr>
           <a:lstStyle/>
           <a:p>
-            <a:r>
-              <a:rPr lang="en-US" altLang="zh-CN" b="1" dirty="0"/>
-              <a:t>Describe the behavior of the video output? </a:t>
-            </a:r>
-            <a:endParaRPr lang="en-US" altLang="zh-CN" b="1" dirty="0">
-              <a:effectLst/>
+            <a:pPr lvl="0" eaLnBrk="0" fontAlgn="base" hangingPunct="0">
+              <a:spcBef>
+                <a:spcPct val="0"/>
+              </a:spcBef>
+              <a:spcAft>
+                <a:spcPct val="0"/>
+              </a:spcAft>
+            </a:pPr>
+            <a:r>
+              <a:rPr lang="zh-CN" altLang="zh-CN" sz="2000" b="1" dirty="0">
+                <a:solidFill>
+                  <a:srgbClr val="B71E1E"/>
+                </a:solidFill>
+                <a:latin typeface="Arial" panose="020B0604020202020204" pitchFamily="34" charset="0"/>
+                <a:ea typeface="Calibri" panose="020F0502020204030204" pitchFamily="34" charset="0"/>
+              </a:rPr>
+              <a:t>Yes. If data is being sent often, then recovery under a NAK</a:t>
+            </a:r>
+            <a:r>
+              <a:rPr lang="en-US" altLang="zh-CN" sz="2000" b="1">
+                <a:solidFill>
+                  <a:srgbClr val="B71E1E"/>
+                </a:solidFill>
+                <a:latin typeface="Arial" panose="020B0604020202020204" pitchFamily="34" charset="0"/>
+                <a:ea typeface="Calibri" panose="020F0502020204030204" pitchFamily="34" charset="0"/>
+              </a:rPr>
+              <a:t>-</a:t>
+            </a:r>
+            <a:r>
+              <a:rPr lang="zh-CN" altLang="zh-CN" sz="2000" b="1">
+                <a:solidFill>
+                  <a:srgbClr val="B71E1E"/>
+                </a:solidFill>
+                <a:latin typeface="Arial" panose="020B0604020202020204" pitchFamily="34" charset="0"/>
+                <a:ea typeface="Calibri" panose="020F0502020204030204" pitchFamily="34" charset="0"/>
+              </a:rPr>
+              <a:t>only </a:t>
+            </a:r>
+            <a:r>
+              <a:rPr lang="zh-CN" altLang="zh-CN" sz="2000" b="1" dirty="0">
+                <a:solidFill>
+                  <a:srgbClr val="B71E1E"/>
+                </a:solidFill>
+                <a:latin typeface="Arial" panose="020B0604020202020204" pitchFamily="34" charset="0"/>
+                <a:ea typeface="Calibri" panose="020F0502020204030204" pitchFamily="34" charset="0"/>
+              </a:rPr>
+              <a:t>scheme could happen quickly. Moreover, if errors are infrequent, then NAKs are only occasionally sent (when needed). </a:t>
+            </a:r>
+            <a:endParaRPr lang="zh-CN" altLang="zh-CN" sz="900" dirty="0">
+              <a:latin typeface="Arial" panose="020B0604020202020204" pitchFamily="34" charset="0"/>
             </a:endParaRPr>
           </a:p>
         </p:txBody>
@@ -10240,7 +9775,169 @@
     </p:spTree>
     <p:extLst>
       <p:ext uri="{BB962C8B-B14F-4D97-AF65-F5344CB8AC3E}">
-        <p14:creationId xmlns:p14="http://schemas.microsoft.com/office/powerpoint/2010/main" val="746100141"/>
+        <p14:creationId xmlns:p14="http://schemas.microsoft.com/office/powerpoint/2010/main" val="3882663473"/>
+      </p:ext>
+    </p:extLst>
+  </p:cSld>
+  <p:clrMapOvr>
+    <a:masterClrMapping/>
+  </p:clrMapOvr>
+  <p:timing>
+    <p:tnLst>
+      <p:par>
+        <p:cTn id="1" dur="indefinite" restart="never" nodeType="tmRoot">
+          <p:childTnLst>
+            <p:seq concurrent="1" nextAc="seek">
+              <p:cTn id="2" dur="indefinite" nodeType="mainSeq">
+                <p:childTnLst>
+                  <p:par>
+                    <p:cTn id="3" fill="hold">
+                      <p:stCondLst>
+                        <p:cond delay="indefinite"/>
+                      </p:stCondLst>
+                      <p:childTnLst>
+                        <p:par>
+                          <p:cTn id="4" fill="hold">
+                            <p:stCondLst>
+                              <p:cond delay="0"/>
+                            </p:stCondLst>
+                            <p:childTnLst>
+                              <p:par>
+                                <p:cTn id="5" presetID="1" presetClass="entr" presetSubtype="0" fill="hold" grpId="0" nodeType="clickEffect">
+                                  <p:stCondLst>
+                                    <p:cond delay="0"/>
+                                  </p:stCondLst>
+                                  <p:childTnLst>
+                                    <p:set>
+                                      <p:cBhvr>
+                                        <p:cTn id="6" dur="1" fill="hold">
+                                          <p:stCondLst>
+                                            <p:cond delay="0"/>
+                                          </p:stCondLst>
+                                        </p:cTn>
+                                        <p:tgtEl>
+                                          <p:spTgt spid="9"/>
+                                        </p:tgtEl>
+                                        <p:attrNameLst>
+                                          <p:attrName>style.visibility</p:attrName>
+                                        </p:attrNameLst>
+                                      </p:cBhvr>
+                                      <p:to>
+                                        <p:strVal val="visible"/>
+                                      </p:to>
+                                    </p:set>
+                                  </p:childTnLst>
+                                </p:cTn>
+                              </p:par>
+                            </p:childTnLst>
+                          </p:cTn>
+                        </p:par>
+                      </p:childTnLst>
+                    </p:cTn>
+                  </p:par>
+                </p:childTnLst>
+              </p:cTn>
+              <p:prevCondLst>
+                <p:cond evt="onPrev" delay="0">
+                  <p:tgtEl>
+                    <p:sldTgt/>
+                  </p:tgtEl>
+                </p:cond>
+              </p:prevCondLst>
+              <p:nextCondLst>
+                <p:cond evt="onNext" delay="0">
+                  <p:tgtEl>
+                    <p:sldTgt/>
+                  </p:tgtEl>
+                </p:cond>
+              </p:nextCondLst>
+            </p:seq>
+          </p:childTnLst>
+        </p:cTn>
+      </p:par>
+    </p:tnLst>
+    <p:bldLst>
+      <p:bldP spid="9" grpId="0"/>
+    </p:bldLst>
+  </p:timing>
+</p:sld>
+</file>
+
+<file path=ppt/slides/slide3.xml><?xml version="1.0" encoding="utf-8"?>
+<p:sld xmlns:a="http://schemas.openxmlformats.org/drawingml/2006/main" xmlns:r="http://schemas.openxmlformats.org/officeDocument/2006/relationships" xmlns:p="http://schemas.openxmlformats.org/presentationml/2006/main">
+  <p:cSld>
+    <p:spTree>
+      <p:nvGrpSpPr>
+        <p:cNvPr id="1" name=""/>
+        <p:cNvGrpSpPr/>
+        <p:nvPr/>
+      </p:nvGrpSpPr>
+      <p:grpSpPr>
+        <a:xfrm>
+          <a:off x="0" y="0"/>
+          <a:ext cx="0" cy="0"/>
+          <a:chOff x="0" y="0"/>
+          <a:chExt cx="0" cy="0"/>
+        </a:xfrm>
+      </p:grpSpPr>
+      <p:sp>
+        <p:nvSpPr>
+          <p:cNvPr id="2" name="标题 1">
+            <a:extLst>
+              <a:ext uri="{FF2B5EF4-FFF2-40B4-BE49-F238E27FC236}">
+                <a16:creationId xmlns:a16="http://schemas.microsoft.com/office/drawing/2014/main" id="{413607AE-4FC0-ED15-C06D-0D33B6211925}"/>
+              </a:ext>
+            </a:extLst>
+          </p:cNvPr>
+          <p:cNvSpPr>
+            <a:spLocks noGrp="1"/>
+          </p:cNvSpPr>
+          <p:nvPr>
+            <p:ph type="ctrTitle"/>
+          </p:nvPr>
+        </p:nvSpPr>
+        <p:spPr/>
+        <p:txBody>
+          <a:bodyPr/>
+          <a:lstStyle/>
+          <a:p>
+            <a:r>
+              <a:rPr kumimoji="1" lang="en-US" altLang="zh-CN" b="1" dirty="0"/>
+              <a:t>Video Streaming</a:t>
+            </a:r>
+            <a:endParaRPr kumimoji="1" lang="zh-CN" altLang="en-US" b="1" dirty="0"/>
+          </a:p>
+        </p:txBody>
+      </p:sp>
+      <p:sp>
+        <p:nvSpPr>
+          <p:cNvPr id="3" name="副标题 2">
+            <a:extLst>
+              <a:ext uri="{FF2B5EF4-FFF2-40B4-BE49-F238E27FC236}">
+                <a16:creationId xmlns:a16="http://schemas.microsoft.com/office/drawing/2014/main" id="{E15F643D-5A8C-1570-8C8E-13C68855E292}"/>
+              </a:ext>
+            </a:extLst>
+          </p:cNvPr>
+          <p:cNvSpPr>
+            <a:spLocks noGrp="1"/>
+          </p:cNvSpPr>
+          <p:nvPr>
+            <p:ph type="subTitle" idx="1"/>
+          </p:nvPr>
+        </p:nvSpPr>
+        <p:spPr/>
+        <p:txBody>
+          <a:bodyPr/>
+          <a:lstStyle/>
+          <a:p>
+            <a:endParaRPr kumimoji="1" lang="zh-CN" altLang="en-US"/>
+          </a:p>
+        </p:txBody>
+      </p:sp>
+    </p:spTree>
+    <p:extLst>
+      <p:ext uri="{BB962C8B-B14F-4D97-AF65-F5344CB8AC3E}">
+        <p14:creationId xmlns:p14="http://schemas.microsoft.com/office/powerpoint/2010/main" val="223323704"/>
       </p:ext>
     </p:extLst>
   </p:cSld>
@@ -10250,7 +9947,7 @@
 </p:sld>
 </file>
 
-<file path=ppt/slides/slide5.xml><?xml version="1.0" encoding="utf-8"?>
+<file path=ppt/slides/slide4.xml><?xml version="1.0" encoding="utf-8"?>
 <p:sld xmlns:a="http://schemas.openxmlformats.org/drawingml/2006/main" xmlns:r="http://schemas.openxmlformats.org/officeDocument/2006/relationships" xmlns:p="http://schemas.openxmlformats.org/presentationml/2006/main">
   <p:cSld>
     <p:spTree>
@@ -10540,12 +10237,277 @@
           </a:p>
         </p:txBody>
       </p:sp>
-      <p:sp>
-        <p:nvSpPr>
-          <p:cNvPr id="6" name="文本框 5">
-            <a:extLst>
-              <a:ext uri="{FF2B5EF4-FFF2-40B4-BE49-F238E27FC236}">
-                <a16:creationId xmlns:a16="http://schemas.microsoft.com/office/drawing/2014/main" id="{3272AB98-FEB9-BA41-8381-4271E43F2E34}"/>
+    </p:spTree>
+    <p:extLst>
+      <p:ext uri="{BB962C8B-B14F-4D97-AF65-F5344CB8AC3E}">
+        <p14:creationId xmlns:p14="http://schemas.microsoft.com/office/powerpoint/2010/main" val="746100141"/>
+      </p:ext>
+    </p:extLst>
+  </p:cSld>
+  <p:clrMapOvr>
+    <a:masterClrMapping/>
+  </p:clrMapOvr>
+</p:sld>
+</file>
+
+<file path=ppt/slides/slide5.xml><?xml version="1.0" encoding="utf-8"?>
+<p:sld xmlns:a="http://schemas.openxmlformats.org/drawingml/2006/main" xmlns:r="http://schemas.openxmlformats.org/officeDocument/2006/relationships" xmlns:p="http://schemas.openxmlformats.org/presentationml/2006/main">
+  <p:cSld>
+    <p:spTree>
+      <p:nvGrpSpPr>
+        <p:cNvPr id="1" name=""/>
+        <p:cNvGrpSpPr/>
+        <p:nvPr/>
+      </p:nvGrpSpPr>
+      <p:grpSpPr>
+        <a:xfrm>
+          <a:off x="0" y="0"/>
+          <a:ext cx="0" cy="0"/>
+          <a:chOff x="0" y="0"/>
+          <a:chExt cx="0" cy="0"/>
+        </a:xfrm>
+      </p:grpSpPr>
+      <p:sp>
+        <p:nvSpPr>
+          <p:cNvPr id="2" name="Title 1">
+            <a:extLst>
+              <a:ext uri="{FF2B5EF4-FFF2-40B4-BE49-F238E27FC236}">
+                <a16:creationId xmlns:a16="http://schemas.microsoft.com/office/drawing/2014/main" id="{45C79BA1-37A3-5741-B0A1-E64646E4283C}"/>
+              </a:ext>
+            </a:extLst>
+          </p:cNvPr>
+          <p:cNvSpPr>
+            <a:spLocks noGrp="1"/>
+          </p:cNvSpPr>
+          <p:nvPr>
+            <p:ph type="title"/>
+          </p:nvPr>
+        </p:nvSpPr>
+        <p:spPr/>
+        <p:txBody>
+          <a:bodyPr/>
+          <a:lstStyle/>
+          <a:p>
+            <a:r>
+              <a:rPr lang="en-US" altLang="zh-CN" b="1" dirty="0"/>
+              <a:t>Exercise</a:t>
+            </a:r>
+            <a:r>
+              <a:rPr lang="zh-CN" altLang="en-US" b="1" dirty="0"/>
+              <a:t> </a:t>
+            </a:r>
+            <a:r>
+              <a:rPr lang="en-US" b="1" dirty="0"/>
+              <a:t>- Q1</a:t>
+            </a:r>
+            <a:r>
+              <a:rPr lang="zh-CN" altLang="en-US" b="1" dirty="0"/>
+              <a:t> </a:t>
+            </a:r>
+            <a:r>
+              <a:rPr lang="en-US" altLang="zh-CN" b="1" dirty="0"/>
+              <a:t>HTTP</a:t>
+            </a:r>
+            <a:r>
+              <a:rPr lang="zh-CN" altLang="en-US" b="1" dirty="0"/>
+              <a:t> </a:t>
+            </a:r>
+            <a:r>
+              <a:rPr lang="en-US" altLang="zh-CN" b="1" dirty="0"/>
+              <a:t>Streaming</a:t>
+            </a:r>
+            <a:endParaRPr lang="en-US" b="1" dirty="0"/>
+          </a:p>
+        </p:txBody>
+      </p:sp>
+      <p:sp>
+        <p:nvSpPr>
+          <p:cNvPr id="3" name="Content Placeholder 2">
+            <a:extLst>
+              <a:ext uri="{FF2B5EF4-FFF2-40B4-BE49-F238E27FC236}">
+                <a16:creationId xmlns:a16="http://schemas.microsoft.com/office/drawing/2014/main" id="{8F20472D-613F-3748-9CBD-88055CDB4B08}"/>
+              </a:ext>
+            </a:extLst>
+          </p:cNvPr>
+          <p:cNvSpPr>
+            <a:spLocks noGrp="1"/>
+          </p:cNvSpPr>
+          <p:nvPr>
+            <p:ph idx="1"/>
+          </p:nvPr>
+        </p:nvSpPr>
+        <p:spPr>
+          <a:xfrm>
+            <a:off x="838200" y="1632427"/>
+            <a:ext cx="10515600" cy="2705735"/>
+          </a:xfrm>
+        </p:spPr>
+        <p:txBody>
+          <a:bodyPr>
+            <a:normAutofit fontScale="77500" lnSpcReduction="20000"/>
+          </a:bodyPr>
+          <a:lstStyle/>
+          <a:p>
+            <a:pPr marL="0" indent="0">
+              <a:buNone/>
+            </a:pPr>
+            <a:r>
+              <a:rPr lang="zh-CN" altLang="zh-CN" sz="2400" dirty="0">
+                <a:latin typeface="Arial" panose="020B0604020202020204" pitchFamily="34" charset="0"/>
+                <a:ea typeface="GillSans" panose="020B0502020104020203" pitchFamily="34" charset="-79"/>
+              </a:rPr>
+              <a:t>Consider a simple HTTP streaming model.</a:t>
+            </a:r>
+            <a:br>
+              <a:rPr lang="zh-CN" altLang="zh-CN" sz="2400" dirty="0">
+                <a:latin typeface="Arial" panose="020B0604020202020204" pitchFamily="34" charset="0"/>
+                <a:ea typeface="GillSans" panose="020B0502020104020203" pitchFamily="34" charset="-79"/>
+              </a:rPr>
+            </a:br>
+            <a:endParaRPr lang="en-US" altLang="zh-CN" sz="2400" dirty="0">
+              <a:latin typeface="Arial" panose="020B0604020202020204" pitchFamily="34" charset="0"/>
+              <a:ea typeface="GillSans" panose="020B0502020104020203" pitchFamily="34" charset="-79"/>
+            </a:endParaRPr>
+          </a:p>
+          <a:p>
+            <a:r>
+              <a:rPr lang="en-US" altLang="zh-CN" dirty="0"/>
+              <a:t>𝑄 is the number of bits that must be buffered before the client application begins playout. </a:t>
+            </a:r>
+          </a:p>
+          <a:p>
+            <a:r>
+              <a:rPr lang="en-US" altLang="zh-CN" dirty="0"/>
+              <a:t>𝑟 is the video consumption rate.</a:t>
+            </a:r>
+          </a:p>
+          <a:p>
+            <a:r>
+              <a:rPr lang="en-US" altLang="zh-CN" dirty="0"/>
+              <a:t>𝑥 is the bits sending rate whenever the client buffer is not full. </a:t>
+            </a:r>
+            <a:endParaRPr lang="en-US" altLang="zh-CN" sz="1600" dirty="0"/>
+          </a:p>
+          <a:p>
+            <a:r>
+              <a:rPr lang="en-US" altLang="zh-CN" dirty="0"/>
+              <a:t>Also assume that 𝑥 &lt; 𝑟.</a:t>
+            </a:r>
+          </a:p>
+          <a:p>
+            <a:pPr marL="0" indent="0">
+              <a:buNone/>
+            </a:pPr>
+            <a:br>
+              <a:rPr lang="en-US" altLang="zh-CN" dirty="0"/>
+            </a:br>
+            <a:endParaRPr lang="zh-CN" altLang="zh-CN" sz="1600" dirty="0">
+              <a:latin typeface="Arial" panose="020B0604020202020204" pitchFamily="34" charset="0"/>
+            </a:endParaRPr>
+          </a:p>
+          <a:p>
+            <a:pPr marL="0" indent="0">
+              <a:buNone/>
+            </a:pPr>
+            <a:endParaRPr lang="en-US" sz="2400" dirty="0"/>
+          </a:p>
+        </p:txBody>
+      </p:sp>
+      <p:sp>
+        <p:nvSpPr>
+          <p:cNvPr id="4" name="Rectangle 2">
+            <a:extLst>
+              <a:ext uri="{FF2B5EF4-FFF2-40B4-BE49-F238E27FC236}">
+                <a16:creationId xmlns:a16="http://schemas.microsoft.com/office/drawing/2014/main" id="{3A7EC6F6-3A9C-6A4E-9F5B-60AABA1D48A4}"/>
+              </a:ext>
+            </a:extLst>
+          </p:cNvPr>
+          <p:cNvSpPr>
+            <a:spLocks noChangeArrowheads="1"/>
+          </p:cNvSpPr>
+          <p:nvPr/>
+        </p:nvSpPr>
+        <p:spPr bwMode="auto">
+          <a:xfrm>
+            <a:off x="0" y="43934"/>
+            <a:ext cx="184731" cy="369332"/>
+          </a:xfrm>
+          <a:prstGeom prst="rect">
+            <a:avLst/>
+          </a:prstGeom>
+          <a:solidFill>
+            <a:srgbClr val="FFFFFF"/>
+          </a:solidFill>
+          <a:ln>
+            <a:noFill/>
+          </a:ln>
+          <a:effectLst/>
+          <a:extLst>
+            <a:ext uri="{91240B29-F687-4F45-9708-019B960494DF}">
+              <a14:hiddenLine xmlns:a14="http://schemas.microsoft.com/office/drawing/2010/main" w="9525">
+                <a:solidFill>
+                  <a:schemeClr val="tx1"/>
+                </a:solidFill>
+                <a:miter lim="800000"/>
+                <a:headEnd/>
+                <a:tailEnd/>
+              </a14:hiddenLine>
+            </a:ext>
+            <a:ext uri="{AF507438-7753-43E0-B8FC-AC1667EBCBE1}">
+              <a14:hiddenEffects xmlns:a14="http://schemas.microsoft.com/office/drawing/2010/main">
+                <a:effectLst>
+                  <a:outerShdw dist="35921" dir="2700000" algn="ctr" rotWithShape="0">
+                    <a:schemeClr val="bg2"/>
+                  </a:outerShdw>
+                </a:effectLst>
+              </a14:hiddenEffects>
+            </a:ext>
+          </a:extLst>
+        </p:spPr>
+        <p:txBody>
+          <a:bodyPr vert="horz" wrap="none" lIns="91440" tIns="45720" rIns="91440" bIns="45720" numCol="1" anchor="ctr" anchorCtr="0" compatLnSpc="1">
+            <a:prstTxWarp prst="textNoShape">
+              <a:avLst/>
+            </a:prstTxWarp>
+            <a:spAutoFit/>
+          </a:bodyPr>
+          <a:lstStyle/>
+          <a:p>
+            <a:pPr marL="0" marR="0" lvl="0" indent="0" algn="l" defTabSz="914400" rtl="0" eaLnBrk="0" fontAlgn="base" latinLnBrk="0" hangingPunct="0">
+              <a:lnSpc>
+                <a:spcPct val="100000"/>
+              </a:lnSpc>
+              <a:spcBef>
+                <a:spcPct val="0"/>
+              </a:spcBef>
+              <a:spcAft>
+                <a:spcPct val="0"/>
+              </a:spcAft>
+              <a:buClrTx/>
+              <a:buSzTx/>
+              <a:buFontTx/>
+              <a:buNone/>
+              <a:tabLst/>
+            </a:pPr>
+            <a:endParaRPr kumimoji="0" lang="zh-CN" altLang="zh-CN" sz="1800" b="0" i="0" u="none" strike="noStrike" cap="none" normalizeH="0" baseline="0" dirty="0">
+              <a:ln>
+                <a:noFill/>
+              </a:ln>
+              <a:solidFill>
+                <a:schemeClr val="tx1"/>
+              </a:solidFill>
+              <a:effectLst/>
+              <a:latin typeface="Arial" panose="020B0604020202020204" pitchFamily="34" charset="0"/>
+            </a:endParaRPr>
+          </a:p>
+        </p:txBody>
+      </p:sp>
+      <p:sp>
+        <p:nvSpPr>
+          <p:cNvPr id="5" name="文本框 4">
+            <a:extLst>
+              <a:ext uri="{FF2B5EF4-FFF2-40B4-BE49-F238E27FC236}">
+                <a16:creationId xmlns:a16="http://schemas.microsoft.com/office/drawing/2014/main" id="{FE188F2A-4142-E048-B3A0-3DF53FF7B70D}"/>
               </a:ext>
             </a:extLst>
           </p:cNvPr>
@@ -10554,8 +10516,8 @@
         </p:nvSpPr>
         <p:spPr>
           <a:xfrm>
-            <a:off x="838200" y="4856241"/>
-            <a:ext cx="3962400" cy="369332"/>
+            <a:off x="838200" y="4279900"/>
+            <a:ext cx="5210480" cy="400110"/>
           </a:xfrm>
           <a:prstGeom prst="rect">
             <a:avLst/>
@@ -10569,7 +10531,45 @@
           <a:lstStyle/>
           <a:p>
             <a:r>
-              <a:rPr lang="en-US" altLang="zh-CN" b="1" dirty="0">
+              <a:rPr lang="en-US" altLang="zh-CN" sz="2000" b="1" dirty="0"/>
+              <a:t>Describe the behavior of the video output? </a:t>
+            </a:r>
+            <a:endParaRPr lang="en-US" altLang="zh-CN" sz="2000" b="1" dirty="0">
+              <a:effectLst/>
+            </a:endParaRPr>
+          </a:p>
+        </p:txBody>
+      </p:sp>
+      <p:sp>
+        <p:nvSpPr>
+          <p:cNvPr id="6" name="文本框 5">
+            <a:extLst>
+              <a:ext uri="{FF2B5EF4-FFF2-40B4-BE49-F238E27FC236}">
+                <a16:creationId xmlns:a16="http://schemas.microsoft.com/office/drawing/2014/main" id="{3272AB98-FEB9-BA41-8381-4271E43F2E34}"/>
+              </a:ext>
+            </a:extLst>
+          </p:cNvPr>
+          <p:cNvSpPr txBox="1"/>
+          <p:nvPr/>
+        </p:nvSpPr>
+        <p:spPr>
+          <a:xfrm>
+            <a:off x="838200" y="4856241"/>
+            <a:ext cx="4453890" cy="400110"/>
+          </a:xfrm>
+          <a:prstGeom prst="rect">
+            <a:avLst/>
+          </a:prstGeom>
+          <a:noFill/>
+        </p:spPr>
+        <p:txBody>
+          <a:bodyPr wrap="square" rtlCol="0">
+            <a:spAutoFit/>
+          </a:bodyPr>
+          <a:lstStyle/>
+          <a:p>
+            <a:r>
+              <a:rPr lang="en-US" altLang="zh-CN" sz="2000" b="1" dirty="0">
                 <a:solidFill>
                   <a:srgbClr val="FF0000"/>
                 </a:solidFill>
@@ -10937,7 +10937,7 @@
         <p:spPr>
           <a:xfrm>
             <a:off x="838200" y="4002901"/>
-            <a:ext cx="5713676" cy="923330"/>
+            <a:ext cx="6328410" cy="1015663"/>
           </a:xfrm>
           <a:prstGeom prst="rect">
             <a:avLst/>
@@ -10951,19 +10951,19 @@
           <a:lstStyle/>
           <a:p>
             <a:r>
-              <a:rPr lang="en-US" altLang="zh-CN" b="1" dirty="0"/>
+              <a:rPr lang="en-US" altLang="zh-CN" sz="2000" b="1" dirty="0"/>
               <a:t>Suppose the buffer starts out empty.</a:t>
             </a:r>
             <a:br>
-              <a:rPr lang="en-US" altLang="zh-CN" b="1" dirty="0"/>
+              <a:rPr lang="en-US" altLang="zh-CN" sz="2000" b="1" dirty="0"/>
             </a:br>
             <a:r>
-              <a:rPr lang="en-US" altLang="zh-CN" b="1" dirty="0"/>
+              <a:rPr lang="en-US" altLang="zh-CN" sz="2000" b="1" dirty="0"/>
               <a:t>How long will it be before the video can begin playout? </a:t>
             </a:r>
           </a:p>
           <a:p>
-            <a:endParaRPr kumimoji="1" lang="zh-CN" altLang="en-US" b="1" dirty="0"/>
+            <a:endParaRPr kumimoji="1" lang="zh-CN" altLang="en-US" sz="2000" b="1" dirty="0"/>
           </a:p>
         </p:txBody>
       </p:sp>
@@ -11247,7 +11247,7 @@
         <p:spPr>
           <a:xfrm>
             <a:off x="838200" y="4018803"/>
-            <a:ext cx="5713676" cy="646331"/>
+            <a:ext cx="6305550" cy="707886"/>
           </a:xfrm>
           <a:prstGeom prst="rect">
             <a:avLst/>
@@ -11261,14 +11261,14 @@
           <a:lstStyle/>
           <a:p>
             <a:r>
-              <a:rPr lang="en-US" altLang="zh-CN" b="1" dirty="0"/>
+              <a:rPr lang="en-US" altLang="zh-CN" sz="2000" b="1" dirty="0"/>
               <a:t>Suppose the buffer starts out empty.</a:t>
             </a:r>
             <a:br>
-              <a:rPr lang="en-US" altLang="zh-CN" b="1" dirty="0"/>
+              <a:rPr lang="en-US" altLang="zh-CN" sz="2000" b="1" dirty="0"/>
             </a:br>
             <a:r>
-              <a:rPr lang="en-US" altLang="zh-CN" b="1" dirty="0"/>
+              <a:rPr lang="en-US" altLang="zh-CN" sz="2000" b="1" dirty="0"/>
               <a:t>How long will it be before the video can begin playout? </a:t>
             </a:r>
           </a:p>
@@ -11288,8 +11288,8 @@
         </p:nvSpPr>
         <p:spPr>
           <a:xfrm>
-            <a:off x="838200" y="4741565"/>
-            <a:ext cx="2159000" cy="369332"/>
+            <a:off x="838199" y="4741565"/>
+            <a:ext cx="2382649" cy="400110"/>
           </a:xfrm>
           <a:prstGeom prst="rect">
             <a:avLst/>
@@ -11303,7 +11303,7 @@
           <a:lstStyle/>
           <a:p>
             <a:r>
-              <a:rPr lang="en-US" altLang="zh-CN" b="1" dirty="0">
+              <a:rPr lang="en-US" altLang="zh-CN" sz="2000" b="1" dirty="0">
                 <a:solidFill>
                   <a:srgbClr val="FF0000"/>
                 </a:solidFill>
@@ -11311,7 +11311,7 @@
               <a:t>Q</a:t>
             </a:r>
             <a:r>
-              <a:rPr lang="zh-CN" altLang="en-US" b="1" dirty="0">
+              <a:rPr lang="zh-CN" altLang="en-US" sz="2000" b="1" dirty="0">
                 <a:solidFill>
                   <a:srgbClr val="FF0000"/>
                 </a:solidFill>
@@ -11319,7 +11319,7 @@
               <a:t> </a:t>
             </a:r>
             <a:r>
-              <a:rPr lang="en-US" altLang="zh-CN" b="1" dirty="0">
+              <a:rPr lang="en-US" altLang="zh-CN" sz="2000" b="1" dirty="0">
                 <a:solidFill>
                   <a:srgbClr val="FF0000"/>
                 </a:solidFill>
@@ -11687,7 +11687,7 @@
         <p:spPr>
           <a:xfrm>
             <a:off x="838200" y="4059664"/>
-            <a:ext cx="5588000" cy="646331"/>
+            <a:ext cx="6305550" cy="707886"/>
           </a:xfrm>
           <a:prstGeom prst="rect">
             <a:avLst/>
@@ -11701,16 +11701,16 @@
           <a:lstStyle/>
           <a:p>
             <a:r>
-              <a:rPr lang="en-US" altLang="zh-CN" b="1" dirty="0"/>
+              <a:rPr lang="en-US" altLang="zh-CN" sz="2000" b="1" dirty="0"/>
               <a:t>Assume the number of bits in buffer currently is Z (&gt; 𝑄). </a:t>
             </a:r>
           </a:p>
           <a:p>
             <a:r>
-              <a:rPr lang="en-US" altLang="zh-CN" b="1" dirty="0"/>
+              <a:rPr lang="en-US" altLang="zh-CN" sz="2000" b="1" dirty="0"/>
               <a:t>How long will the playout last? </a:t>
             </a:r>
-            <a:endParaRPr lang="en-US" altLang="zh-CN" b="1" dirty="0">
+            <a:endParaRPr lang="en-US" altLang="zh-CN" sz="2000" b="1" dirty="0">
               <a:effectLst/>
             </a:endParaRPr>
           </a:p>
@@ -11996,7 +11996,7 @@
         <p:spPr>
           <a:xfrm>
             <a:off x="838200" y="4059664"/>
-            <a:ext cx="5588000" cy="646331"/>
+            <a:ext cx="6134100" cy="707886"/>
           </a:xfrm>
           <a:prstGeom prst="rect">
             <a:avLst/>
@@ -12010,16 +12010,16 @@
           <a:lstStyle/>
           <a:p>
             <a:r>
-              <a:rPr lang="en-US" altLang="zh-CN" b="1" dirty="0"/>
+              <a:rPr lang="en-US" altLang="zh-CN" sz="2000" b="1" dirty="0"/>
               <a:t>Assume the number of bits in buffer currently is Z (&gt; 𝑄). </a:t>
             </a:r>
           </a:p>
           <a:p>
             <a:r>
-              <a:rPr lang="en-US" altLang="zh-CN" b="1" dirty="0"/>
+              <a:rPr lang="en-US" altLang="zh-CN" sz="2000" b="1" dirty="0"/>
               <a:t>How long will the playout last? </a:t>
             </a:r>
-            <a:endParaRPr lang="en-US" altLang="zh-CN" b="1" dirty="0">
+            <a:endParaRPr lang="en-US" altLang="zh-CN" sz="2000" b="1" dirty="0">
               <a:effectLst/>
             </a:endParaRPr>
           </a:p>
@@ -12039,8 +12039,8 @@
         </p:nvSpPr>
         <p:spPr>
           <a:xfrm>
-            <a:off x="838200" y="4856241"/>
-            <a:ext cx="1816100" cy="369332"/>
+            <a:off x="838199" y="4856241"/>
+            <a:ext cx="1993583" cy="400110"/>
           </a:xfrm>
           <a:prstGeom prst="rect">
             <a:avLst/>
@@ -12054,7 +12054,7 @@
           <a:lstStyle/>
           <a:p>
             <a:r>
-              <a:rPr kumimoji="1" lang="en-US" altLang="zh-CN" b="1" dirty="0">
+              <a:rPr kumimoji="1" lang="en-US" altLang="zh-CN" sz="2000" b="1" dirty="0">
                 <a:solidFill>
                   <a:srgbClr val="FF0000"/>
                 </a:solidFill>
@@ -12062,7 +12062,7 @@
               <a:t>Z</a:t>
             </a:r>
             <a:r>
-              <a:rPr kumimoji="1" lang="zh-CN" altLang="en-US" b="1" dirty="0">
+              <a:rPr kumimoji="1" lang="zh-CN" altLang="en-US" sz="2000" b="1" dirty="0">
                 <a:solidFill>
                   <a:srgbClr val="FF0000"/>
                 </a:solidFill>
@@ -12070,7 +12070,7 @@
               <a:t> </a:t>
             </a:r>
             <a:r>
-              <a:rPr kumimoji="1" lang="en-US" altLang="zh-CN" b="1" dirty="0">
+              <a:rPr kumimoji="1" lang="en-US" altLang="zh-CN" sz="2000" b="1" dirty="0">
                 <a:solidFill>
                   <a:srgbClr val="FF0000"/>
                 </a:solidFill>
@@ -12078,7 +12078,7 @@
               <a:t>/</a:t>
             </a:r>
             <a:r>
-              <a:rPr kumimoji="1" lang="zh-CN" altLang="en-US" b="1" dirty="0">
+              <a:rPr kumimoji="1" lang="zh-CN" altLang="en-US" sz="2000" b="1" dirty="0">
                 <a:solidFill>
                   <a:srgbClr val="FF0000"/>
                 </a:solidFill>
@@ -12086,7 +12086,7 @@
               <a:t> </a:t>
             </a:r>
             <a:r>
-              <a:rPr kumimoji="1" lang="en-US" altLang="zh-CN" b="1" dirty="0">
+              <a:rPr kumimoji="1" lang="en-US" altLang="zh-CN" sz="2000" b="1" dirty="0">
                 <a:solidFill>
                   <a:srgbClr val="FF0000"/>
                 </a:solidFill>
@@ -12094,7 +12094,7 @@
               <a:t>(r</a:t>
             </a:r>
             <a:r>
-              <a:rPr kumimoji="1" lang="zh-CN" altLang="en-US" b="1" dirty="0">
+              <a:rPr kumimoji="1" lang="zh-CN" altLang="en-US" sz="2000" b="1" dirty="0">
                 <a:solidFill>
                   <a:srgbClr val="FF0000"/>
                 </a:solidFill>
@@ -12102,7 +12102,7 @@
               <a:t> </a:t>
             </a:r>
             <a:r>
-              <a:rPr kumimoji="1" lang="en-US" altLang="zh-CN" b="1" dirty="0">
+              <a:rPr kumimoji="1" lang="en-US" altLang="zh-CN" sz="2000" b="1" dirty="0">
                 <a:solidFill>
                   <a:srgbClr val="FF0000"/>
                 </a:solidFill>
@@ -12110,7 +12110,7 @@
               <a:t>-</a:t>
             </a:r>
             <a:r>
-              <a:rPr kumimoji="1" lang="zh-CN" altLang="en-US" b="1" dirty="0">
+              <a:rPr kumimoji="1" lang="zh-CN" altLang="en-US" sz="2000" b="1" dirty="0">
                 <a:solidFill>
                   <a:srgbClr val="FF0000"/>
                 </a:solidFill>
@@ -12118,14 +12118,14 @@
               <a:t> </a:t>
             </a:r>
             <a:r>
-              <a:rPr kumimoji="1" lang="en-US" altLang="zh-CN" b="1" dirty="0">
+              <a:rPr kumimoji="1" lang="en-US" altLang="zh-CN" sz="2000" b="1" dirty="0">
                 <a:solidFill>
                   <a:srgbClr val="FF0000"/>
                 </a:solidFill>
               </a:rPr>
               <a:t>x)</a:t>
             </a:r>
-            <a:endParaRPr kumimoji="1" lang="zh-CN" altLang="en-US" b="1" dirty="0">
+            <a:endParaRPr kumimoji="1" lang="zh-CN" altLang="en-US" sz="2000" b="1" dirty="0">
               <a:solidFill>
                 <a:srgbClr val="FF0000"/>
               </a:solidFill>

</xml_diff>